<commit_message>
feat(p04): audit materi pertemuan 4, sederhanakan seluruh kode slide ke standar minimal Flutter tanpa design overhead, dan sinkronkan link GitHub
</commit_message>
<xml_diff>
--- a/03_slide_presentasi/PERTEMUAN_04_Form_Handling_dan_GoRouter.pptx
+++ b/03_slide_presentasi/PERTEMUAN_04_Form_Handling_dan_GoRouter.pptx
@@ -11976,7 +11976,7 @@
         <p:spPr>
           <a:xfrm>
             <a:off x="5669280" y="2121408"/>
-            <a:ext cx="5486400" cy="3977639"/>
+            <a:ext cx="5486400" cy="3364992"/>
           </a:xfrm>
           <a:prstGeom prst="rect">
             <a:avLst/>
@@ -12038,6 +12038,142 @@
             <a:br/>
             <a:r>
               <a:t>#   go_router: ^14.8.0  # Terpasang otomatis rapi!</a:t>
+            </a:r>
+          </a:p>
+        </p:txBody>
+      </p:sp>
+      <p:sp>
+        <p:nvSpPr>
+          <p:cNvPr id="15" name="Rectangle 14"/>
+          <p:cNvSpPr/>
+          <p:nvPr/>
+        </p:nvSpPr>
+        <p:spPr>
+          <a:xfrm>
+            <a:off x="5660136" y="5669280"/>
+            <a:ext cx="5608015" cy="548640"/>
+          </a:xfrm>
+          <a:prstGeom prst="rect">
+            <a:avLst/>
+          </a:prstGeom>
+          <a:solidFill>
+            <a:srgbClr val="000000"/>
+          </a:solidFill>
+          <a:ln>
+            <a:noFill/>
+          </a:ln>
+        </p:spPr>
+        <p:style>
+          <a:lnRef idx="1">
+            <a:schemeClr val="accent1"/>
+          </a:lnRef>
+          <a:fillRef idx="3">
+            <a:schemeClr val="accent1"/>
+          </a:fillRef>
+          <a:effectRef idx="2">
+            <a:schemeClr val="accent1"/>
+          </a:effectRef>
+          <a:fontRef idx="minor">
+            <a:schemeClr val="lt1"/>
+          </a:fontRef>
+        </p:style>
+        <p:txBody>
+          <a:bodyPr rtlCol="0" anchor="ctr"/>
+          <a:lstStyle/>
+          <a:p>
+            <a:pPr algn="ctr"/>
+          </a:p>
+        </p:txBody>
+      </p:sp>
+      <p:sp>
+        <p:nvSpPr>
+          <p:cNvPr id="16" name="Rectangle 15"/>
+          <p:cNvSpPr/>
+          <p:nvPr/>
+        </p:nvSpPr>
+        <p:spPr>
+          <a:xfrm>
+            <a:off x="5623560" y="5632704"/>
+            <a:ext cx="5608015" cy="548640"/>
+          </a:xfrm>
+          <a:prstGeom prst="rect">
+            <a:avLst/>
+          </a:prstGeom>
+          <a:solidFill>
+            <a:srgbClr val="FFE600"/>
+          </a:solidFill>
+          <a:ln w="25400">
+            <a:solidFill>
+              <a:srgbClr val="000000"/>
+            </a:solidFill>
+          </a:ln>
+        </p:spPr>
+        <p:style>
+          <a:lnRef idx="1">
+            <a:schemeClr val="accent1"/>
+          </a:lnRef>
+          <a:fillRef idx="3">
+            <a:schemeClr val="accent1"/>
+          </a:fillRef>
+          <a:effectRef idx="2">
+            <a:schemeClr val="accent1"/>
+          </a:effectRef>
+          <a:fontRef idx="minor">
+            <a:schemeClr val="lt1"/>
+          </a:fontRef>
+        </p:style>
+        <p:txBody>
+          <a:bodyPr rtlCol="0" anchor="ctr"/>
+          <a:lstStyle/>
+          <a:p>
+            <a:pPr algn="ctr"/>
+          </a:p>
+        </p:txBody>
+      </p:sp>
+      <p:sp>
+        <p:nvSpPr>
+          <p:cNvPr id="17" name="TextBox 16"/>
+          <p:cNvSpPr txBox="1"/>
+          <p:nvPr/>
+        </p:nvSpPr>
+        <p:spPr>
+          <a:xfrm>
+            <a:off x="5696712" y="5660136"/>
+            <a:ext cx="5461711" cy="493776"/>
+          </a:xfrm>
+          <a:prstGeom prst="rect">
+            <a:avLst/>
+          </a:prstGeom>
+          <a:noFill/>
+        </p:spPr>
+        <p:txBody>
+          <a:bodyPr wrap="square">
+            <a:spAutoFit/>
+          </a:bodyPr>
+          <a:lstStyle/>
+          <a:p>
+            <a:r>
+              <a:rPr sz="960" b="1">
+                <a:solidFill>
+                  <a:srgbClr val="000000"/>
+                </a:solidFill>
+                <a:latin typeface="Segoe UI"/>
+                <a:hlinkClick r:id="rId2"/>
+              </a:rPr>
+              <a:t>▶ BUKA KODE LENGKAP DI GITHUB (slide_02_persiapan_tools_dan_gorouter.dart)</a:t>
+            </a:r>
+          </a:p>
+          <a:p>
+            <a:pPr>
+              <a:defRPr sz="760">
+                <a:solidFill>
+                  <a:srgbClr val="3C3C3C"/>
+                </a:solidFill>
+                <a:latin typeface="Segoe UI"/>
+              </a:defRPr>
+            </a:pPr>
+            <a:r>
+              <a:t>💡 Buka di browser / salin source code: github.com/antonprafanto/mobile2026</a:t>
             </a:r>
           </a:p>
         </p:txBody>

</xml_diff>

<commit_message>
fix(p04): perjelas redaksi teks slide 03 textformfield vs textfield agar ramah mahasiswa awam
</commit_message>
<xml_diff>
--- a/03_slide_presentasi/PERTEMUAN_04_Form_Handling_dan_GoRouter.pptx
+++ b/03_slide_presentasi/PERTEMUAN_04_Form_Handling_dan_GoRouter.pptx
@@ -12537,7 +12537,7 @@
               </a:defRPr>
             </a:pPr>
             <a:r>
-              <a:t>■  Kapan memakai TextField biasa? Sangat cocok untuk input mandiri tanpa form terikat (misal: kolom pencarian 'Search Bar' di AppBar).</a:t>
+              <a:t>■  Kapan memakai TextField biasa? Sangat cocok untuk input mandiri tanpa validasi (misal: kolom pencarian 'Search Bar' di AppBar).</a:t>
             </a:r>
           </a:p>
           <a:p>
@@ -12553,7 +12553,7 @@
               </a:defRPr>
             </a:pPr>
             <a:r>
-              <a:t>■  Kapan memakai TextFormField? Wajib digunakan di dalam formulir pendaftaran, login, transaksi, atau survei.</a:t>
+              <a:t>■  Kapan memakai TextFormField? Wajib digunakan di formulir pendaftaran/login yang butuh pengecekan data sebelum dikirim.</a:t>
             </a:r>
           </a:p>
           <a:p>
@@ -12569,7 +12569,7 @@
               </a:defRPr>
             </a:pPr>
             <a:r>
-              <a:t>■  TextFormField adalah TextField pintar yang terintegrasi ke ekosistem Form, mendukung properti 'validator', 'onSaved', dan pesan galat otomatis.</a:t>
+              <a:t>■  Keunggulan TextFormField: Jika isian salah, teks peringatan merah (error text) otomatis muncul tepat di bawah kotak input tanpa perlu setState manual.</a:t>
             </a:r>
           </a:p>
           <a:p>
@@ -12585,7 +12585,7 @@
               </a:defRPr>
             </a:pPr>
             <a:r>
-              <a:t>■  Sitasi Resmi: Flutter Cookbook - Build a form with validation (docs.flutter.dev/cookbook/forms/validation).</a:t>
+              <a:t>■  Terintegrasi dengan Form: Mendukung fungsi pengecekan 'validator' dan dapat diperiksa serentak via '_formKey.currentState!.validate()'.</a:t>
             </a:r>
           </a:p>
           <a:p>

</xml_diff>

<commit_message>
refactor(presentation): eliminasi istilah 'awam' dan standarisasi narasi akademis profesional di seluruh slide P1-P7, kode, dan markdown
</commit_message>
<xml_diff>
--- a/03_slide_presentasi/PERTEMUAN_04_Form_Handling_dan_GoRouter.pptx
+++ b/03_slide_presentasi/PERTEMUAN_04_Form_Handling_dan_GoRouter.pptx
@@ -7272,7 +7272,7 @@
             </a:r>
             <a:br/>
             <a:r>
-              <a:t>  // Penanganan Galat Halaman 404 Ramah Awam:</a:t>
+              <a:t>  // Penanganan Galat Halaman 404 Terstruktur:</a:t>
             </a:r>
             <a:br/>
             <a:r>
@@ -13396,7 +13396,7 @@
               </a:defRPr>
             </a:pPr>
             <a:r>
-              <a:t>■  ⚠️ Peringatan Kritis Mahasiswa Awam: Controller WAJIB dimatikan menggunakan method '_ctrl.dispose()' di dalam blok dispose().</a:t>
+              <a:t>■  ⚠️ Peringatan Kritis Pengembang: Controller WAJIB dimatikan menggunakan method '_ctrl.dispose()' di dalam blok dispose().</a:t>
             </a:r>
           </a:p>
           <a:p>

</xml_diff>

<commit_message>
style(presentation): perbarui tipografi font pada slide Pertemuan 04 dan abaikan berkas sementara Office
</commit_message>
<xml_diff>
--- a/03_slide_presentasi/PERTEMUAN_04_Form_Handling_dan_GoRouter.pptx
+++ b/03_slide_presentasi/PERTEMUAN_04_Form_Handling_dan_GoRouter.pptx
@@ -5,27 +5,27 @@
     <p:sldMasterId id="2147483648" r:id="rId1"/>
   </p:sldMasterIdLst>
   <p:sldIdLst>
-    <p:sldId id="256" r:id="rId7"/>
-    <p:sldId id="257" r:id="rId8"/>
-    <p:sldId id="258" r:id="rId9"/>
-    <p:sldId id="259" r:id="rId10"/>
-    <p:sldId id="260" r:id="rId11"/>
-    <p:sldId id="261" r:id="rId12"/>
-    <p:sldId id="262" r:id="rId13"/>
-    <p:sldId id="263" r:id="rId14"/>
-    <p:sldId id="264" r:id="rId15"/>
-    <p:sldId id="265" r:id="rId16"/>
-    <p:sldId id="266" r:id="rId17"/>
-    <p:sldId id="267" r:id="rId18"/>
-    <p:sldId id="268" r:id="rId19"/>
-    <p:sldId id="269" r:id="rId20"/>
-    <p:sldId id="270" r:id="rId21"/>
-    <p:sldId id="271" r:id="rId22"/>
-    <p:sldId id="272" r:id="rId23"/>
-    <p:sldId id="273" r:id="rId24"/>
-    <p:sldId id="274" r:id="rId25"/>
+    <p:sldId id="256" r:id="rId2"/>
+    <p:sldId id="257" r:id="rId3"/>
+    <p:sldId id="258" r:id="rId4"/>
+    <p:sldId id="259" r:id="rId5"/>
+    <p:sldId id="260" r:id="rId6"/>
+    <p:sldId id="261" r:id="rId7"/>
+    <p:sldId id="262" r:id="rId8"/>
+    <p:sldId id="263" r:id="rId9"/>
+    <p:sldId id="264" r:id="rId10"/>
+    <p:sldId id="265" r:id="rId11"/>
+    <p:sldId id="266" r:id="rId12"/>
+    <p:sldId id="267" r:id="rId13"/>
+    <p:sldId id="268" r:id="rId14"/>
+    <p:sldId id="269" r:id="rId15"/>
+    <p:sldId id="270" r:id="rId16"/>
+    <p:sldId id="271" r:id="rId17"/>
+    <p:sldId id="272" r:id="rId18"/>
+    <p:sldId id="273" r:id="rId19"/>
+    <p:sldId id="274" r:id="rId20"/>
   </p:sldIdLst>
-  <p:sldSz cx="12191695" cy="6858000" type="screen4x3"/>
+  <p:sldSz cx="12192000" cy="6858000"/>
   <p:notesSz cx="6858000" cy="9144000"/>
   <p:defaultTextStyle>
     <a:defPPr>
@@ -122,6 +122,22 @@
       </a:defRPr>
     </a:lvl9pPr>
   </p:defaultTextStyle>
+  <p:extLst>
+    <p:ext uri="{EFAFB233-063F-42B5-8137-9DF3F51BA10A}">
+      <p15:sldGuideLst xmlns:p15="http://schemas.microsoft.com/office/powerpoint/2012/main">
+        <p15:guide id="1" orient="horz" pos="2160">
+          <p15:clr>
+            <a:srgbClr val="A4A3A4"/>
+          </p15:clr>
+        </p15:guide>
+        <p15:guide id="2" pos="2880">
+          <p15:clr>
+            <a:srgbClr val="A4A3A4"/>
+          </p15:clr>
+        </p15:guide>
+      </p15:sldGuideLst>
+    </p:ext>
+  </p:extLst>
 </p:presentation>
 </file>
 
@@ -163,10 +179,9 @@
           <a:lstStyle/>
           <a:p>
             <a:r>
-              <a:rPr lang="en-US" smtClean="0"/>
+              <a:rPr lang="en-US"/>
               <a:t>Click to edit Master title style</a:t>
             </a:r>
-            <a:endParaRPr lang="en-US"/>
           </a:p>
         </p:txBody>
       </p:sp>
@@ -282,10 +297,9 @@
           </a:lstStyle>
           <a:p>
             <a:r>
-              <a:rPr lang="en-US" smtClean="0"/>
+              <a:rPr lang="en-US"/>
               <a:t>Click to edit Master subtitle style</a:t>
             </a:r>
-            <a:endParaRPr lang="en-US"/>
           </a:p>
         </p:txBody>
       </p:sp>
@@ -306,7 +320,7 @@
           <a:p>
             <a:fld id="{5BCAD085-E8A6-8845-BD4E-CB4CCA059FC4}" type="datetimeFigureOut">
               <a:rPr lang="en-US" smtClean="0"/>
-              <a:t>1/27/13</a:t>
+              <a:t>9/10/2026</a:t>
             </a:fld>
             <a:endParaRPr lang="en-US"/>
           </a:p>
@@ -400,10 +414,9 @@
           <a:lstStyle/>
           <a:p>
             <a:r>
-              <a:rPr lang="en-US" smtClean="0"/>
+              <a:rPr lang="en-US"/>
               <a:t>Click to edit Master title style</a:t>
             </a:r>
-            <a:endParaRPr lang="en-US"/>
           </a:p>
         </p:txBody>
       </p:sp>
@@ -424,38 +437,37 @@
           <a:p>
             <a:pPr lvl="0"/>
             <a:r>
-              <a:rPr lang="en-US" smtClean="0"/>
+              <a:rPr lang="en-US"/>
               <a:t>Click to edit Master text styles</a:t>
             </a:r>
           </a:p>
           <a:p>
             <a:pPr lvl="1"/>
             <a:r>
-              <a:rPr lang="en-US" smtClean="0"/>
+              <a:rPr lang="en-US"/>
               <a:t>Second level</a:t>
             </a:r>
           </a:p>
           <a:p>
             <a:pPr lvl="2"/>
             <a:r>
-              <a:rPr lang="en-US" smtClean="0"/>
+              <a:rPr lang="en-US"/>
               <a:t>Third level</a:t>
             </a:r>
           </a:p>
           <a:p>
             <a:pPr lvl="3"/>
             <a:r>
-              <a:rPr lang="en-US" smtClean="0"/>
+              <a:rPr lang="en-US"/>
               <a:t>Fourth level</a:t>
             </a:r>
           </a:p>
           <a:p>
             <a:pPr lvl="4"/>
             <a:r>
-              <a:rPr lang="en-US" smtClean="0"/>
+              <a:rPr lang="en-US"/>
               <a:t>Fifth level</a:t>
             </a:r>
-            <a:endParaRPr lang="en-US"/>
           </a:p>
         </p:txBody>
       </p:sp>
@@ -476,7 +488,7 @@
           <a:p>
             <a:fld id="{5BCAD085-E8A6-8845-BD4E-CB4CCA059FC4}" type="datetimeFigureOut">
               <a:rPr lang="en-US" smtClean="0"/>
-              <a:t>1/27/13</a:t>
+              <a:t>9/10/2026</a:t>
             </a:fld>
             <a:endParaRPr lang="en-US"/>
           </a:p>
@@ -575,10 +587,9 @@
           <a:lstStyle/>
           <a:p>
             <a:r>
-              <a:rPr lang="en-US" smtClean="0"/>
+              <a:rPr lang="en-US"/>
               <a:t>Click to edit Master title style</a:t>
             </a:r>
-            <a:endParaRPr lang="en-US"/>
           </a:p>
         </p:txBody>
       </p:sp>
@@ -604,38 +615,37 @@
           <a:p>
             <a:pPr lvl="0"/>
             <a:r>
-              <a:rPr lang="en-US" smtClean="0"/>
+              <a:rPr lang="en-US"/>
               <a:t>Click to edit Master text styles</a:t>
             </a:r>
           </a:p>
           <a:p>
             <a:pPr lvl="1"/>
             <a:r>
-              <a:rPr lang="en-US" smtClean="0"/>
+              <a:rPr lang="en-US"/>
               <a:t>Second level</a:t>
             </a:r>
           </a:p>
           <a:p>
             <a:pPr lvl="2"/>
             <a:r>
-              <a:rPr lang="en-US" smtClean="0"/>
+              <a:rPr lang="en-US"/>
               <a:t>Third level</a:t>
             </a:r>
           </a:p>
           <a:p>
             <a:pPr lvl="3"/>
             <a:r>
-              <a:rPr lang="en-US" smtClean="0"/>
+              <a:rPr lang="en-US"/>
               <a:t>Fourth level</a:t>
             </a:r>
           </a:p>
           <a:p>
             <a:pPr lvl="4"/>
             <a:r>
-              <a:rPr lang="en-US" smtClean="0"/>
+              <a:rPr lang="en-US"/>
               <a:t>Fifth level</a:t>
             </a:r>
-            <a:endParaRPr lang="en-US"/>
           </a:p>
         </p:txBody>
       </p:sp>
@@ -656,7 +666,7 @@
           <a:p>
             <a:fld id="{5BCAD085-E8A6-8845-BD4E-CB4CCA059FC4}" type="datetimeFigureOut">
               <a:rPr lang="en-US" smtClean="0"/>
-              <a:t>1/27/13</a:t>
+              <a:t>9/10/2026</a:t>
             </a:fld>
             <a:endParaRPr lang="en-US"/>
           </a:p>
@@ -750,10 +760,9 @@
           <a:lstStyle/>
           <a:p>
             <a:r>
-              <a:rPr lang="en-US" smtClean="0"/>
+              <a:rPr lang="en-US"/>
               <a:t>Click to edit Master title style</a:t>
             </a:r>
-            <a:endParaRPr lang="en-US"/>
           </a:p>
         </p:txBody>
       </p:sp>
@@ -774,38 +783,37 @@
           <a:p>
             <a:pPr lvl="0"/>
             <a:r>
-              <a:rPr lang="en-US" smtClean="0"/>
+              <a:rPr lang="en-US"/>
               <a:t>Click to edit Master text styles</a:t>
             </a:r>
           </a:p>
           <a:p>
             <a:pPr lvl="1"/>
             <a:r>
-              <a:rPr lang="en-US" smtClean="0"/>
+              <a:rPr lang="en-US"/>
               <a:t>Second level</a:t>
             </a:r>
           </a:p>
           <a:p>
             <a:pPr lvl="2"/>
             <a:r>
-              <a:rPr lang="en-US" smtClean="0"/>
+              <a:rPr lang="en-US"/>
               <a:t>Third level</a:t>
             </a:r>
           </a:p>
           <a:p>
             <a:pPr lvl="3"/>
             <a:r>
-              <a:rPr lang="en-US" smtClean="0"/>
+              <a:rPr lang="en-US"/>
               <a:t>Fourth level</a:t>
             </a:r>
           </a:p>
           <a:p>
             <a:pPr lvl="4"/>
             <a:r>
-              <a:rPr lang="en-US" smtClean="0"/>
+              <a:rPr lang="en-US"/>
               <a:t>Fifth level</a:t>
             </a:r>
-            <a:endParaRPr lang="en-US"/>
           </a:p>
         </p:txBody>
       </p:sp>
@@ -826,7 +834,7 @@
           <a:p>
             <a:fld id="{5BCAD085-E8A6-8845-BD4E-CB4CCA059FC4}" type="datetimeFigureOut">
               <a:rPr lang="en-US" smtClean="0"/>
-              <a:t>1/27/13</a:t>
+              <a:t>9/10/2026</a:t>
             </a:fld>
             <a:endParaRPr lang="en-US"/>
           </a:p>
@@ -929,10 +937,9 @@
           </a:lstStyle>
           <a:p>
             <a:r>
-              <a:rPr lang="en-US" smtClean="0"/>
+              <a:rPr lang="en-US"/>
               <a:t>Click to edit Master title style</a:t>
             </a:r>
-            <a:endParaRPr lang="en-US"/>
           </a:p>
         </p:txBody>
       </p:sp>
@@ -1049,7 +1056,7 @@
           <a:p>
             <a:pPr lvl="0"/>
             <a:r>
-              <a:rPr lang="en-US" smtClean="0"/>
+              <a:rPr lang="en-US"/>
               <a:t>Click to edit Master text styles</a:t>
             </a:r>
           </a:p>
@@ -1072,7 +1079,7 @@
           <a:p>
             <a:fld id="{5BCAD085-E8A6-8845-BD4E-CB4CCA059FC4}" type="datetimeFigureOut">
               <a:rPr lang="en-US" smtClean="0"/>
-              <a:t>1/27/13</a:t>
+              <a:t>9/10/2026</a:t>
             </a:fld>
             <a:endParaRPr lang="en-US"/>
           </a:p>
@@ -1166,10 +1173,9 @@
           <a:lstStyle/>
           <a:p>
             <a:r>
-              <a:rPr lang="en-US" smtClean="0"/>
+              <a:rPr lang="en-US"/>
               <a:t>Click to edit Master title style</a:t>
             </a:r>
-            <a:endParaRPr lang="en-US"/>
           </a:p>
         </p:txBody>
       </p:sp>
@@ -1223,38 +1229,37 @@
           <a:p>
             <a:pPr lvl="0"/>
             <a:r>
-              <a:rPr lang="en-US" smtClean="0"/>
+              <a:rPr lang="en-US"/>
               <a:t>Click to edit Master text styles</a:t>
             </a:r>
           </a:p>
           <a:p>
             <a:pPr lvl="1"/>
             <a:r>
-              <a:rPr lang="en-US" smtClean="0"/>
+              <a:rPr lang="en-US"/>
               <a:t>Second level</a:t>
             </a:r>
           </a:p>
           <a:p>
             <a:pPr lvl="2"/>
             <a:r>
-              <a:rPr lang="en-US" smtClean="0"/>
+              <a:rPr lang="en-US"/>
               <a:t>Third level</a:t>
             </a:r>
           </a:p>
           <a:p>
             <a:pPr lvl="3"/>
             <a:r>
-              <a:rPr lang="en-US" smtClean="0"/>
+              <a:rPr lang="en-US"/>
               <a:t>Fourth level</a:t>
             </a:r>
           </a:p>
           <a:p>
             <a:pPr lvl="4"/>
             <a:r>
-              <a:rPr lang="en-US" smtClean="0"/>
+              <a:rPr lang="en-US"/>
               <a:t>Fifth level</a:t>
             </a:r>
-            <a:endParaRPr lang="en-US"/>
           </a:p>
         </p:txBody>
       </p:sp>
@@ -1308,38 +1313,37 @@
           <a:p>
             <a:pPr lvl="0"/>
             <a:r>
-              <a:rPr lang="en-US" smtClean="0"/>
+              <a:rPr lang="en-US"/>
               <a:t>Click to edit Master text styles</a:t>
             </a:r>
           </a:p>
           <a:p>
             <a:pPr lvl="1"/>
             <a:r>
-              <a:rPr lang="en-US" smtClean="0"/>
+              <a:rPr lang="en-US"/>
               <a:t>Second level</a:t>
             </a:r>
           </a:p>
           <a:p>
             <a:pPr lvl="2"/>
             <a:r>
-              <a:rPr lang="en-US" smtClean="0"/>
+              <a:rPr lang="en-US"/>
               <a:t>Third level</a:t>
             </a:r>
           </a:p>
           <a:p>
             <a:pPr lvl="3"/>
             <a:r>
-              <a:rPr lang="en-US" smtClean="0"/>
+              <a:rPr lang="en-US"/>
               <a:t>Fourth level</a:t>
             </a:r>
           </a:p>
           <a:p>
             <a:pPr lvl="4"/>
             <a:r>
-              <a:rPr lang="en-US" smtClean="0"/>
+              <a:rPr lang="en-US"/>
               <a:t>Fifth level</a:t>
             </a:r>
-            <a:endParaRPr lang="en-US"/>
           </a:p>
         </p:txBody>
       </p:sp>
@@ -1360,7 +1364,7 @@
           <a:p>
             <a:fld id="{5BCAD085-E8A6-8845-BD4E-CB4CCA059FC4}" type="datetimeFigureOut">
               <a:rPr lang="en-US" smtClean="0"/>
-              <a:t>1/27/13</a:t>
+              <a:t>9/10/2026</a:t>
             </a:fld>
             <a:endParaRPr lang="en-US"/>
           </a:p>
@@ -1458,10 +1462,9 @@
           </a:lstStyle>
           <a:p>
             <a:r>
-              <a:rPr lang="en-US" smtClean="0"/>
+              <a:rPr lang="en-US"/>
               <a:t>Click to edit Master title style</a:t>
             </a:r>
-            <a:endParaRPr lang="en-US"/>
           </a:p>
         </p:txBody>
       </p:sp>
@@ -1524,7 +1527,7 @@
           <a:p>
             <a:pPr lvl="0"/>
             <a:r>
-              <a:rPr lang="en-US" smtClean="0"/>
+              <a:rPr lang="en-US"/>
               <a:t>Click to edit Master text styles</a:t>
             </a:r>
           </a:p>
@@ -1580,38 +1583,37 @@
           <a:p>
             <a:pPr lvl="0"/>
             <a:r>
-              <a:rPr lang="en-US" smtClean="0"/>
+              <a:rPr lang="en-US"/>
               <a:t>Click to edit Master text styles</a:t>
             </a:r>
           </a:p>
           <a:p>
             <a:pPr lvl="1"/>
             <a:r>
-              <a:rPr lang="en-US" smtClean="0"/>
+              <a:rPr lang="en-US"/>
               <a:t>Second level</a:t>
             </a:r>
           </a:p>
           <a:p>
             <a:pPr lvl="2"/>
             <a:r>
-              <a:rPr lang="en-US" smtClean="0"/>
+              <a:rPr lang="en-US"/>
               <a:t>Third level</a:t>
             </a:r>
           </a:p>
           <a:p>
             <a:pPr lvl="3"/>
             <a:r>
-              <a:rPr lang="en-US" smtClean="0"/>
+              <a:rPr lang="en-US"/>
               <a:t>Fourth level</a:t>
             </a:r>
           </a:p>
           <a:p>
             <a:pPr lvl="4"/>
             <a:r>
-              <a:rPr lang="en-US" smtClean="0"/>
+              <a:rPr lang="en-US"/>
               <a:t>Fifth level</a:t>
             </a:r>
-            <a:endParaRPr lang="en-US"/>
           </a:p>
         </p:txBody>
       </p:sp>
@@ -1674,7 +1676,7 @@
           <a:p>
             <a:pPr lvl="0"/>
             <a:r>
-              <a:rPr lang="en-US" smtClean="0"/>
+              <a:rPr lang="en-US"/>
               <a:t>Click to edit Master text styles</a:t>
             </a:r>
           </a:p>
@@ -1730,38 +1732,37 @@
           <a:p>
             <a:pPr lvl="0"/>
             <a:r>
-              <a:rPr lang="en-US" smtClean="0"/>
+              <a:rPr lang="en-US"/>
               <a:t>Click to edit Master text styles</a:t>
             </a:r>
           </a:p>
           <a:p>
             <a:pPr lvl="1"/>
             <a:r>
-              <a:rPr lang="en-US" smtClean="0"/>
+              <a:rPr lang="en-US"/>
               <a:t>Second level</a:t>
             </a:r>
           </a:p>
           <a:p>
             <a:pPr lvl="2"/>
             <a:r>
-              <a:rPr lang="en-US" smtClean="0"/>
+              <a:rPr lang="en-US"/>
               <a:t>Third level</a:t>
             </a:r>
           </a:p>
           <a:p>
             <a:pPr lvl="3"/>
             <a:r>
-              <a:rPr lang="en-US" smtClean="0"/>
+              <a:rPr lang="en-US"/>
               <a:t>Fourth level</a:t>
             </a:r>
           </a:p>
           <a:p>
             <a:pPr lvl="4"/>
             <a:r>
-              <a:rPr lang="en-US" smtClean="0"/>
+              <a:rPr lang="en-US"/>
               <a:t>Fifth level</a:t>
             </a:r>
-            <a:endParaRPr lang="en-US"/>
           </a:p>
         </p:txBody>
       </p:sp>
@@ -1782,7 +1783,7 @@
           <a:p>
             <a:fld id="{5BCAD085-E8A6-8845-BD4E-CB4CCA059FC4}" type="datetimeFigureOut">
               <a:rPr lang="en-US" smtClean="0"/>
-              <a:t>1/27/13</a:t>
+              <a:t>9/10/2026</a:t>
             </a:fld>
             <a:endParaRPr lang="en-US"/>
           </a:p>
@@ -1876,10 +1877,9 @@
           <a:lstStyle/>
           <a:p>
             <a:r>
-              <a:rPr lang="en-US" smtClean="0"/>
+              <a:rPr lang="en-US"/>
               <a:t>Click to edit Master title style</a:t>
             </a:r>
-            <a:endParaRPr lang="en-US"/>
           </a:p>
         </p:txBody>
       </p:sp>
@@ -1900,7 +1900,7 @@
           <a:p>
             <a:fld id="{5BCAD085-E8A6-8845-BD4E-CB4CCA059FC4}" type="datetimeFigureOut">
               <a:rPr lang="en-US" smtClean="0"/>
-              <a:t>1/27/13</a:t>
+              <a:t>9/10/2026</a:t>
             </a:fld>
             <a:endParaRPr lang="en-US"/>
           </a:p>
@@ -1995,7 +1995,7 @@
           <a:p>
             <a:fld id="{5BCAD085-E8A6-8845-BD4E-CB4CCA059FC4}" type="datetimeFigureOut">
               <a:rPr lang="en-US" smtClean="0"/>
-              <a:t>1/27/13</a:t>
+              <a:t>9/10/2026</a:t>
             </a:fld>
             <a:endParaRPr lang="en-US"/>
           </a:p>
@@ -2098,10 +2098,9 @@
           </a:lstStyle>
           <a:p>
             <a:r>
-              <a:rPr lang="en-US" smtClean="0"/>
+              <a:rPr lang="en-US"/>
               <a:t>Click to edit Master title style</a:t>
             </a:r>
-            <a:endParaRPr lang="en-US"/>
           </a:p>
         </p:txBody>
       </p:sp>
@@ -2155,38 +2154,37 @@
           <a:p>
             <a:pPr lvl="0"/>
             <a:r>
-              <a:rPr lang="en-US" smtClean="0"/>
+              <a:rPr lang="en-US"/>
               <a:t>Click to edit Master text styles</a:t>
             </a:r>
           </a:p>
           <a:p>
             <a:pPr lvl="1"/>
             <a:r>
-              <a:rPr lang="en-US" smtClean="0"/>
+              <a:rPr lang="en-US"/>
               <a:t>Second level</a:t>
             </a:r>
           </a:p>
           <a:p>
             <a:pPr lvl="2"/>
             <a:r>
-              <a:rPr lang="en-US" smtClean="0"/>
+              <a:rPr lang="en-US"/>
               <a:t>Third level</a:t>
             </a:r>
           </a:p>
           <a:p>
             <a:pPr lvl="3"/>
             <a:r>
-              <a:rPr lang="en-US" smtClean="0"/>
+              <a:rPr lang="en-US"/>
               <a:t>Fourth level</a:t>
             </a:r>
           </a:p>
           <a:p>
             <a:pPr lvl="4"/>
             <a:r>
-              <a:rPr lang="en-US" smtClean="0"/>
+              <a:rPr lang="en-US"/>
               <a:t>Fifth level</a:t>
             </a:r>
-            <a:endParaRPr lang="en-US"/>
           </a:p>
         </p:txBody>
       </p:sp>
@@ -2249,7 +2247,7 @@
           <a:p>
             <a:pPr lvl="0"/>
             <a:r>
-              <a:rPr lang="en-US" smtClean="0"/>
+              <a:rPr lang="en-US"/>
               <a:t>Click to edit Master text styles</a:t>
             </a:r>
           </a:p>
@@ -2272,7 +2270,7 @@
           <a:p>
             <a:fld id="{5BCAD085-E8A6-8845-BD4E-CB4CCA059FC4}" type="datetimeFigureOut">
               <a:rPr lang="en-US" smtClean="0"/>
-              <a:t>1/27/13</a:t>
+              <a:t>9/10/2026</a:t>
             </a:fld>
             <a:endParaRPr lang="en-US"/>
           </a:p>
@@ -2375,10 +2373,9 @@
           </a:lstStyle>
           <a:p>
             <a:r>
-              <a:rPr lang="en-US" smtClean="0"/>
+              <a:rPr lang="en-US"/>
               <a:t>Click to edit Master title style</a:t>
             </a:r>
-            <a:endParaRPr lang="en-US"/>
           </a:p>
         </p:txBody>
       </p:sp>
@@ -2502,7 +2499,7 @@
           <a:p>
             <a:pPr lvl="0"/>
             <a:r>
-              <a:rPr lang="en-US" smtClean="0"/>
+              <a:rPr lang="en-US"/>
               <a:t>Click to edit Master text styles</a:t>
             </a:r>
           </a:p>
@@ -2525,7 +2522,7 @@
           <a:p>
             <a:fld id="{5BCAD085-E8A6-8845-BD4E-CB4CCA059FC4}" type="datetimeFigureOut">
               <a:rPr lang="en-US" smtClean="0"/>
-              <a:t>1/27/13</a:t>
+              <a:t>9/10/2026</a:t>
             </a:fld>
             <a:endParaRPr lang="en-US"/>
           </a:p>
@@ -2634,10 +2631,9 @@
           <a:lstStyle/>
           <a:p>
             <a:r>
-              <a:rPr lang="en-US" smtClean="0"/>
+              <a:rPr lang="en-US"/>
               <a:t>Click to edit Master title style</a:t>
             </a:r>
-            <a:endParaRPr lang="en-US"/>
           </a:p>
         </p:txBody>
       </p:sp>
@@ -2668,38 +2664,37 @@
           <a:p>
             <a:pPr lvl="0"/>
             <a:r>
-              <a:rPr lang="en-US" smtClean="0"/>
+              <a:rPr lang="en-US"/>
               <a:t>Click to edit Master text styles</a:t>
             </a:r>
           </a:p>
           <a:p>
             <a:pPr lvl="1"/>
             <a:r>
-              <a:rPr lang="en-US" smtClean="0"/>
+              <a:rPr lang="en-US"/>
               <a:t>Second level</a:t>
             </a:r>
           </a:p>
           <a:p>
             <a:pPr lvl="2"/>
             <a:r>
-              <a:rPr lang="en-US" smtClean="0"/>
+              <a:rPr lang="en-US"/>
               <a:t>Third level</a:t>
             </a:r>
           </a:p>
           <a:p>
             <a:pPr lvl="3"/>
             <a:r>
-              <a:rPr lang="en-US" smtClean="0"/>
+              <a:rPr lang="en-US"/>
               <a:t>Fourth level</a:t>
             </a:r>
           </a:p>
           <a:p>
             <a:pPr lvl="4"/>
             <a:r>
-              <a:rPr lang="en-US" smtClean="0"/>
+              <a:rPr lang="en-US"/>
               <a:t>Fifth level</a:t>
             </a:r>
-            <a:endParaRPr lang="en-US"/>
           </a:p>
         </p:txBody>
       </p:sp>
@@ -2738,7 +2733,7 @@
           <a:p>
             <a:fld id="{5BCAD085-E8A6-8845-BD4E-CB4CCA059FC4}" type="datetimeFigureOut">
               <a:rPr lang="en-US" smtClean="0"/>
-              <a:t>1/27/13</a:t>
+              <a:t>9/10/2026</a:t>
             </a:fld>
             <a:endParaRPr lang="en-US"/>
           </a:p>
@@ -3097,7 +3092,7 @@
 </file>
 
 <file path=ppt/slides/slide1.xml><?xml version="1.0" encoding="utf-8"?>
-<p:sld xmlns:a="http://schemas.openxmlformats.org/drawingml/2006/main" xmlns:p="http://schemas.openxmlformats.org/presentationml/2006/main" xmlns:r="http://schemas.openxmlformats.org/officeDocument/2006/relationships">
+<p:sld xmlns:a="http://schemas.openxmlformats.org/drawingml/2006/main" xmlns:r="http://schemas.openxmlformats.org/officeDocument/2006/relationships" xmlns:p="http://schemas.openxmlformats.org/presentationml/2006/main">
   <p:cSld>
     <p:spTree>
       <p:nvGrpSpPr>
@@ -3105,7 +3100,14 @@
         <p:cNvGrpSpPr/>
         <p:nvPr/>
       </p:nvGrpSpPr>
-      <p:grpSpPr/>
+      <p:grpSpPr>
+        <a:xfrm>
+          <a:off x="0" y="0"/>
+          <a:ext cx="0" cy="0"/>
+          <a:chOff x="0" y="0"/>
+          <a:chExt cx="0" cy="0"/>
+        </a:xfrm>
+      </p:grpSpPr>
       <p:sp>
         <p:nvSpPr>
           <p:cNvPr id="2" name="Rectangle 1"/>
@@ -3146,6 +3148,7 @@
           <a:lstStyle/>
           <a:p>
             <a:pPr algn="ctr"/>
+            <a:endParaRPr/>
           </a:p>
         </p:txBody>
       </p:sp>
@@ -3189,6 +3192,7 @@
           <a:lstStyle/>
           <a:p>
             <a:pPr algn="ctr"/>
+            <a:endParaRPr/>
           </a:p>
         </p:txBody>
       </p:sp>
@@ -3234,6 +3238,7 @@
           <a:lstStyle/>
           <a:p>
             <a:pPr algn="ctr"/>
+            <a:endParaRPr/>
           </a:p>
         </p:txBody>
       </p:sp>
@@ -3330,7 +3335,7 @@
 </file>
 
 <file path=ppt/slides/slide10.xml><?xml version="1.0" encoding="utf-8"?>
-<p:sld xmlns:a="http://schemas.openxmlformats.org/drawingml/2006/main" xmlns:p="http://schemas.openxmlformats.org/presentationml/2006/main" xmlns:r="http://schemas.openxmlformats.org/officeDocument/2006/relationships">
+<p:sld xmlns:a="http://schemas.openxmlformats.org/drawingml/2006/main" xmlns:r="http://schemas.openxmlformats.org/officeDocument/2006/relationships" xmlns:p="http://schemas.openxmlformats.org/presentationml/2006/main">
   <p:cSld>
     <p:spTree>
       <p:nvGrpSpPr>
@@ -3338,7 +3343,14 @@
         <p:cNvGrpSpPr/>
         <p:nvPr/>
       </p:nvGrpSpPr>
-      <p:grpSpPr/>
+      <p:grpSpPr>
+        <a:xfrm>
+          <a:off x="0" y="0"/>
+          <a:ext cx="0" cy="0"/>
+          <a:chOff x="0" y="0"/>
+          <a:chExt cx="0" cy="0"/>
+        </a:xfrm>
+      </p:grpSpPr>
       <p:sp>
         <p:nvSpPr>
           <p:cNvPr id="2" name="Rectangle 1"/>
@@ -3379,6 +3391,7 @@
           <a:lstStyle/>
           <a:p>
             <a:pPr algn="ctr"/>
+            <a:endParaRPr/>
           </a:p>
         </p:txBody>
       </p:sp>
@@ -3422,6 +3435,7 @@
           <a:lstStyle/>
           <a:p>
             <a:pPr algn="ctr"/>
+            <a:endParaRPr/>
           </a:p>
         </p:txBody>
       </p:sp>
@@ -3467,6 +3481,7 @@
           <a:lstStyle/>
           <a:p>
             <a:pPr algn="ctr"/>
+            <a:endParaRPr/>
           </a:p>
         </p:txBody>
       </p:sp>
@@ -3582,6 +3597,7 @@
           <a:lstStyle/>
           <a:p>
             <a:pPr algn="ctr"/>
+            <a:endParaRPr/>
           </a:p>
         </p:txBody>
       </p:sp>
@@ -3627,6 +3643,7 @@
           <a:lstStyle/>
           <a:p>
             <a:pPr algn="ctr"/>
+            <a:endParaRPr/>
           </a:p>
         </p:txBody>
       </p:sp>
@@ -3786,6 +3803,7 @@
           <a:lstStyle/>
           <a:p>
             <a:pPr algn="ctr"/>
+            <a:endParaRPr/>
           </a:p>
         </p:txBody>
       </p:sp>
@@ -3831,6 +3849,7 @@
           <a:lstStyle/>
           <a:p>
             <a:pPr algn="ctr"/>
+            <a:endParaRPr/>
           </a:p>
         </p:txBody>
       </p:sp>
@@ -3876,6 +3895,7 @@
           <a:lstStyle/>
           <a:p>
             <a:pPr algn="ctr"/>
+            <a:endParaRPr/>
           </a:p>
         </p:txBody>
       </p:sp>
@@ -4047,6 +4067,7 @@
           <a:lstStyle/>
           <a:p>
             <a:pPr algn="ctr"/>
+            <a:endParaRPr/>
           </a:p>
         </p:txBody>
       </p:sp>
@@ -4092,6 +4113,7 @@
           <a:lstStyle/>
           <a:p>
             <a:pPr algn="ctr"/>
+            <a:endParaRPr/>
           </a:p>
         </p:txBody>
       </p:sp>
@@ -4152,7 +4174,7 @@
 </file>
 
 <file path=ppt/slides/slide11.xml><?xml version="1.0" encoding="utf-8"?>
-<p:sld xmlns:a="http://schemas.openxmlformats.org/drawingml/2006/main" xmlns:p="http://schemas.openxmlformats.org/presentationml/2006/main" xmlns:r="http://schemas.openxmlformats.org/officeDocument/2006/relationships">
+<p:sld xmlns:a="http://schemas.openxmlformats.org/drawingml/2006/main" xmlns:r="http://schemas.openxmlformats.org/officeDocument/2006/relationships" xmlns:p="http://schemas.openxmlformats.org/presentationml/2006/main">
   <p:cSld>
     <p:spTree>
       <p:nvGrpSpPr>
@@ -4160,7 +4182,14 @@
         <p:cNvGrpSpPr/>
         <p:nvPr/>
       </p:nvGrpSpPr>
-      <p:grpSpPr/>
+      <p:grpSpPr>
+        <a:xfrm>
+          <a:off x="0" y="0"/>
+          <a:ext cx="0" cy="0"/>
+          <a:chOff x="0" y="0"/>
+          <a:chExt cx="0" cy="0"/>
+        </a:xfrm>
+      </p:grpSpPr>
       <p:sp>
         <p:nvSpPr>
           <p:cNvPr id="2" name="Rectangle 1"/>
@@ -4201,6 +4230,7 @@
           <a:lstStyle/>
           <a:p>
             <a:pPr algn="ctr"/>
+            <a:endParaRPr/>
           </a:p>
         </p:txBody>
       </p:sp>
@@ -4244,6 +4274,7 @@
           <a:lstStyle/>
           <a:p>
             <a:pPr algn="ctr"/>
+            <a:endParaRPr/>
           </a:p>
         </p:txBody>
       </p:sp>
@@ -4289,6 +4320,7 @@
           <a:lstStyle/>
           <a:p>
             <a:pPr algn="ctr"/>
+            <a:endParaRPr/>
           </a:p>
         </p:txBody>
       </p:sp>
@@ -4404,6 +4436,7 @@
           <a:lstStyle/>
           <a:p>
             <a:pPr algn="ctr"/>
+            <a:endParaRPr/>
           </a:p>
         </p:txBody>
       </p:sp>
@@ -4449,6 +4482,7 @@
           <a:lstStyle/>
           <a:p>
             <a:pPr algn="ctr"/>
+            <a:endParaRPr/>
           </a:p>
         </p:txBody>
       </p:sp>
@@ -4608,6 +4642,7 @@
           <a:lstStyle/>
           <a:p>
             <a:pPr algn="ctr"/>
+            <a:endParaRPr/>
           </a:p>
         </p:txBody>
       </p:sp>
@@ -4653,6 +4688,7 @@
           <a:lstStyle/>
           <a:p>
             <a:pPr algn="ctr"/>
+            <a:endParaRPr/>
           </a:p>
         </p:txBody>
       </p:sp>
@@ -4698,6 +4734,7 @@
           <a:lstStyle/>
           <a:p>
             <a:pPr algn="ctr"/>
+            <a:endParaRPr/>
           </a:p>
         </p:txBody>
       </p:sp>
@@ -4877,6 +4914,7 @@
           <a:lstStyle/>
           <a:p>
             <a:pPr algn="ctr"/>
+            <a:endParaRPr/>
           </a:p>
         </p:txBody>
       </p:sp>
@@ -4922,6 +4960,7 @@
           <a:lstStyle/>
           <a:p>
             <a:pPr algn="ctr"/>
+            <a:endParaRPr/>
           </a:p>
         </p:txBody>
       </p:sp>
@@ -4982,7 +5021,7 @@
 </file>
 
 <file path=ppt/slides/slide12.xml><?xml version="1.0" encoding="utf-8"?>
-<p:sld xmlns:a="http://schemas.openxmlformats.org/drawingml/2006/main" xmlns:p="http://schemas.openxmlformats.org/presentationml/2006/main" xmlns:r="http://schemas.openxmlformats.org/officeDocument/2006/relationships">
+<p:sld xmlns:a="http://schemas.openxmlformats.org/drawingml/2006/main" xmlns:r="http://schemas.openxmlformats.org/officeDocument/2006/relationships" xmlns:p="http://schemas.openxmlformats.org/presentationml/2006/main">
   <p:cSld>
     <p:spTree>
       <p:nvGrpSpPr>
@@ -4990,7 +5029,14 @@
         <p:cNvGrpSpPr/>
         <p:nvPr/>
       </p:nvGrpSpPr>
-      <p:grpSpPr/>
+      <p:grpSpPr>
+        <a:xfrm>
+          <a:off x="0" y="0"/>
+          <a:ext cx="0" cy="0"/>
+          <a:chOff x="0" y="0"/>
+          <a:chExt cx="0" cy="0"/>
+        </a:xfrm>
+      </p:grpSpPr>
       <p:sp>
         <p:nvSpPr>
           <p:cNvPr id="2" name="Rectangle 1"/>
@@ -5031,6 +5077,7 @@
           <a:lstStyle/>
           <a:p>
             <a:pPr algn="ctr"/>
+            <a:endParaRPr/>
           </a:p>
         </p:txBody>
       </p:sp>
@@ -5074,6 +5121,7 @@
           <a:lstStyle/>
           <a:p>
             <a:pPr algn="ctr"/>
+            <a:endParaRPr/>
           </a:p>
         </p:txBody>
       </p:sp>
@@ -5119,6 +5167,7 @@
           <a:lstStyle/>
           <a:p>
             <a:pPr algn="ctr"/>
+            <a:endParaRPr/>
           </a:p>
         </p:txBody>
       </p:sp>
@@ -5234,6 +5283,7 @@
           <a:lstStyle/>
           <a:p>
             <a:pPr algn="ctr"/>
+            <a:endParaRPr/>
           </a:p>
         </p:txBody>
       </p:sp>
@@ -5279,6 +5329,7 @@
           <a:lstStyle/>
           <a:p>
             <a:pPr algn="ctr"/>
+            <a:endParaRPr/>
           </a:p>
         </p:txBody>
       </p:sp>
@@ -5438,6 +5489,7 @@
           <a:lstStyle/>
           <a:p>
             <a:pPr algn="ctr"/>
+            <a:endParaRPr/>
           </a:p>
         </p:txBody>
       </p:sp>
@@ -5483,6 +5535,7 @@
           <a:lstStyle/>
           <a:p>
             <a:pPr algn="ctr"/>
+            <a:endParaRPr/>
           </a:p>
         </p:txBody>
       </p:sp>
@@ -5528,6 +5581,7 @@
           <a:lstStyle/>
           <a:p>
             <a:pPr algn="ctr"/>
+            <a:endParaRPr/>
           </a:p>
         </p:txBody>
       </p:sp>
@@ -5707,6 +5761,7 @@
           <a:lstStyle/>
           <a:p>
             <a:pPr algn="ctr"/>
+            <a:endParaRPr/>
           </a:p>
         </p:txBody>
       </p:sp>
@@ -5752,6 +5807,7 @@
           <a:lstStyle/>
           <a:p>
             <a:pPr algn="ctr"/>
+            <a:endParaRPr/>
           </a:p>
         </p:txBody>
       </p:sp>
@@ -5812,7 +5868,7 @@
 </file>
 
 <file path=ppt/slides/slide13.xml><?xml version="1.0" encoding="utf-8"?>
-<p:sld xmlns:a="http://schemas.openxmlformats.org/drawingml/2006/main" xmlns:p="http://schemas.openxmlformats.org/presentationml/2006/main" xmlns:r="http://schemas.openxmlformats.org/officeDocument/2006/relationships">
+<p:sld xmlns:a="http://schemas.openxmlformats.org/drawingml/2006/main" xmlns:r="http://schemas.openxmlformats.org/officeDocument/2006/relationships" xmlns:p="http://schemas.openxmlformats.org/presentationml/2006/main">
   <p:cSld>
     <p:spTree>
       <p:nvGrpSpPr>
@@ -5820,7 +5876,14 @@
         <p:cNvGrpSpPr/>
         <p:nvPr/>
       </p:nvGrpSpPr>
-      <p:grpSpPr/>
+      <p:grpSpPr>
+        <a:xfrm>
+          <a:off x="0" y="0"/>
+          <a:ext cx="0" cy="0"/>
+          <a:chOff x="0" y="0"/>
+          <a:chExt cx="0" cy="0"/>
+        </a:xfrm>
+      </p:grpSpPr>
       <p:sp>
         <p:nvSpPr>
           <p:cNvPr id="2" name="Rectangle 1"/>
@@ -5861,6 +5924,7 @@
           <a:lstStyle/>
           <a:p>
             <a:pPr algn="ctr"/>
+            <a:endParaRPr/>
           </a:p>
         </p:txBody>
       </p:sp>
@@ -5904,6 +5968,7 @@
           <a:lstStyle/>
           <a:p>
             <a:pPr algn="ctr"/>
+            <a:endParaRPr/>
           </a:p>
         </p:txBody>
       </p:sp>
@@ -5949,6 +6014,7 @@
           <a:lstStyle/>
           <a:p>
             <a:pPr algn="ctr"/>
+            <a:endParaRPr/>
           </a:p>
         </p:txBody>
       </p:sp>
@@ -6064,6 +6130,7 @@
           <a:lstStyle/>
           <a:p>
             <a:pPr algn="ctr"/>
+            <a:endParaRPr/>
           </a:p>
         </p:txBody>
       </p:sp>
@@ -6109,6 +6176,7 @@
           <a:lstStyle/>
           <a:p>
             <a:pPr algn="ctr"/>
+            <a:endParaRPr/>
           </a:p>
         </p:txBody>
       </p:sp>
@@ -6268,6 +6336,7 @@
           <a:lstStyle/>
           <a:p>
             <a:pPr algn="ctr"/>
+            <a:endParaRPr/>
           </a:p>
         </p:txBody>
       </p:sp>
@@ -6313,6 +6382,7 @@
           <a:lstStyle/>
           <a:p>
             <a:pPr algn="ctr"/>
+            <a:endParaRPr/>
           </a:p>
         </p:txBody>
       </p:sp>
@@ -6358,6 +6428,7 @@
           <a:lstStyle/>
           <a:p>
             <a:pPr algn="ctr"/>
+            <a:endParaRPr/>
           </a:p>
         </p:txBody>
       </p:sp>
@@ -6511,6 +6582,7 @@
           <a:lstStyle/>
           <a:p>
             <a:pPr algn="ctr"/>
+            <a:endParaRPr/>
           </a:p>
         </p:txBody>
       </p:sp>
@@ -6556,6 +6628,7 @@
           <a:lstStyle/>
           <a:p>
             <a:pPr algn="ctr"/>
+            <a:endParaRPr/>
           </a:p>
         </p:txBody>
       </p:sp>
@@ -6616,7 +6689,7 @@
 </file>
 
 <file path=ppt/slides/slide14.xml><?xml version="1.0" encoding="utf-8"?>
-<p:sld xmlns:a="http://schemas.openxmlformats.org/drawingml/2006/main" xmlns:p="http://schemas.openxmlformats.org/presentationml/2006/main" xmlns:r="http://schemas.openxmlformats.org/officeDocument/2006/relationships">
+<p:sld xmlns:a="http://schemas.openxmlformats.org/drawingml/2006/main" xmlns:r="http://schemas.openxmlformats.org/officeDocument/2006/relationships" xmlns:p="http://schemas.openxmlformats.org/presentationml/2006/main">
   <p:cSld>
     <p:spTree>
       <p:nvGrpSpPr>
@@ -6624,7 +6697,14 @@
         <p:cNvGrpSpPr/>
         <p:nvPr/>
       </p:nvGrpSpPr>
-      <p:grpSpPr/>
+      <p:grpSpPr>
+        <a:xfrm>
+          <a:off x="0" y="0"/>
+          <a:ext cx="0" cy="0"/>
+          <a:chOff x="0" y="0"/>
+          <a:chExt cx="0" cy="0"/>
+        </a:xfrm>
+      </p:grpSpPr>
       <p:sp>
         <p:nvSpPr>
           <p:cNvPr id="2" name="Rectangle 1"/>
@@ -6665,6 +6745,7 @@
           <a:lstStyle/>
           <a:p>
             <a:pPr algn="ctr"/>
+            <a:endParaRPr/>
           </a:p>
         </p:txBody>
       </p:sp>
@@ -6708,6 +6789,7 @@
           <a:lstStyle/>
           <a:p>
             <a:pPr algn="ctr"/>
+            <a:endParaRPr/>
           </a:p>
         </p:txBody>
       </p:sp>
@@ -6753,6 +6835,7 @@
           <a:lstStyle/>
           <a:p>
             <a:pPr algn="ctr"/>
+            <a:endParaRPr/>
           </a:p>
         </p:txBody>
       </p:sp>
@@ -6868,6 +6951,7 @@
           <a:lstStyle/>
           <a:p>
             <a:pPr algn="ctr"/>
+            <a:endParaRPr/>
           </a:p>
         </p:txBody>
       </p:sp>
@@ -6913,6 +6997,7 @@
           <a:lstStyle/>
           <a:p>
             <a:pPr algn="ctr"/>
+            <a:endParaRPr/>
           </a:p>
         </p:txBody>
       </p:sp>
@@ -7088,6 +7173,7 @@
           <a:lstStyle/>
           <a:p>
             <a:pPr algn="ctr"/>
+            <a:endParaRPr/>
           </a:p>
         </p:txBody>
       </p:sp>
@@ -7133,6 +7219,7 @@
           <a:lstStyle/>
           <a:p>
             <a:pPr algn="ctr"/>
+            <a:endParaRPr/>
           </a:p>
         </p:txBody>
       </p:sp>
@@ -7178,6 +7265,7 @@
           <a:lstStyle/>
           <a:p>
             <a:pPr algn="ctr"/>
+            <a:endParaRPr/>
           </a:p>
         </p:txBody>
       </p:sp>
@@ -7350,6 +7438,7 @@
           <a:lstStyle/>
           <a:p>
             <a:pPr algn="ctr"/>
+            <a:endParaRPr/>
           </a:p>
         </p:txBody>
       </p:sp>
@@ -7395,6 +7484,7 @@
           <a:lstStyle/>
           <a:p>
             <a:pPr algn="ctr"/>
+            <a:endParaRPr/>
           </a:p>
         </p:txBody>
       </p:sp>
@@ -7455,7 +7545,7 @@
 </file>
 
 <file path=ppt/slides/slide15.xml><?xml version="1.0" encoding="utf-8"?>
-<p:sld xmlns:a="http://schemas.openxmlformats.org/drawingml/2006/main" xmlns:p="http://schemas.openxmlformats.org/presentationml/2006/main" xmlns:r="http://schemas.openxmlformats.org/officeDocument/2006/relationships">
+<p:sld xmlns:a="http://schemas.openxmlformats.org/drawingml/2006/main" xmlns:r="http://schemas.openxmlformats.org/officeDocument/2006/relationships" xmlns:p="http://schemas.openxmlformats.org/presentationml/2006/main">
   <p:cSld>
     <p:spTree>
       <p:nvGrpSpPr>
@@ -7463,7 +7553,14 @@
         <p:cNvGrpSpPr/>
         <p:nvPr/>
       </p:nvGrpSpPr>
-      <p:grpSpPr/>
+      <p:grpSpPr>
+        <a:xfrm>
+          <a:off x="0" y="0"/>
+          <a:ext cx="0" cy="0"/>
+          <a:chOff x="0" y="0"/>
+          <a:chExt cx="0" cy="0"/>
+        </a:xfrm>
+      </p:grpSpPr>
       <p:sp>
         <p:nvSpPr>
           <p:cNvPr id="2" name="Rectangle 1"/>
@@ -7504,6 +7601,7 @@
           <a:lstStyle/>
           <a:p>
             <a:pPr algn="ctr"/>
+            <a:endParaRPr/>
           </a:p>
         </p:txBody>
       </p:sp>
@@ -7547,6 +7645,7 @@
           <a:lstStyle/>
           <a:p>
             <a:pPr algn="ctr"/>
+            <a:endParaRPr/>
           </a:p>
         </p:txBody>
       </p:sp>
@@ -7592,6 +7691,7 @@
           <a:lstStyle/>
           <a:p>
             <a:pPr algn="ctr"/>
+            <a:endParaRPr/>
           </a:p>
         </p:txBody>
       </p:sp>
@@ -7707,6 +7807,7 @@
           <a:lstStyle/>
           <a:p>
             <a:pPr algn="ctr"/>
+            <a:endParaRPr/>
           </a:p>
         </p:txBody>
       </p:sp>
@@ -7752,6 +7853,7 @@
           <a:lstStyle/>
           <a:p>
             <a:pPr algn="ctr"/>
+            <a:endParaRPr/>
           </a:p>
         </p:txBody>
       </p:sp>
@@ -7895,6 +7997,7 @@
           <a:lstStyle/>
           <a:p>
             <a:pPr algn="ctr"/>
+            <a:endParaRPr/>
           </a:p>
         </p:txBody>
       </p:sp>
@@ -7940,6 +8043,7 @@
           <a:lstStyle/>
           <a:p>
             <a:pPr algn="ctr"/>
+            <a:endParaRPr/>
           </a:p>
         </p:txBody>
       </p:sp>
@@ -7985,6 +8089,7 @@
           <a:lstStyle/>
           <a:p>
             <a:pPr algn="ctr"/>
+            <a:endParaRPr/>
           </a:p>
         </p:txBody>
       </p:sp>
@@ -8146,6 +8251,7 @@
           <a:lstStyle/>
           <a:p>
             <a:pPr algn="ctr"/>
+            <a:endParaRPr/>
           </a:p>
         </p:txBody>
       </p:sp>
@@ -8191,6 +8297,7 @@
           <a:lstStyle/>
           <a:p>
             <a:pPr algn="ctr"/>
+            <a:endParaRPr/>
           </a:p>
         </p:txBody>
       </p:sp>
@@ -8251,7 +8358,7 @@
 </file>
 
 <file path=ppt/slides/slide16.xml><?xml version="1.0" encoding="utf-8"?>
-<p:sld xmlns:a="http://schemas.openxmlformats.org/drawingml/2006/main" xmlns:p="http://schemas.openxmlformats.org/presentationml/2006/main" xmlns:r="http://schemas.openxmlformats.org/officeDocument/2006/relationships">
+<p:sld xmlns:a="http://schemas.openxmlformats.org/drawingml/2006/main" xmlns:r="http://schemas.openxmlformats.org/officeDocument/2006/relationships" xmlns:p="http://schemas.openxmlformats.org/presentationml/2006/main">
   <p:cSld>
     <p:spTree>
       <p:nvGrpSpPr>
@@ -8259,7 +8366,14 @@
         <p:cNvGrpSpPr/>
         <p:nvPr/>
       </p:nvGrpSpPr>
-      <p:grpSpPr/>
+      <p:grpSpPr>
+        <a:xfrm>
+          <a:off x="0" y="0"/>
+          <a:ext cx="0" cy="0"/>
+          <a:chOff x="0" y="0"/>
+          <a:chExt cx="0" cy="0"/>
+        </a:xfrm>
+      </p:grpSpPr>
       <p:sp>
         <p:nvSpPr>
           <p:cNvPr id="2" name="Rectangle 1"/>
@@ -8300,6 +8414,7 @@
           <a:lstStyle/>
           <a:p>
             <a:pPr algn="ctr"/>
+            <a:endParaRPr/>
           </a:p>
         </p:txBody>
       </p:sp>
@@ -8343,6 +8458,7 @@
           <a:lstStyle/>
           <a:p>
             <a:pPr algn="ctr"/>
+            <a:endParaRPr/>
           </a:p>
         </p:txBody>
       </p:sp>
@@ -8388,6 +8504,7 @@
           <a:lstStyle/>
           <a:p>
             <a:pPr algn="ctr"/>
+            <a:endParaRPr/>
           </a:p>
         </p:txBody>
       </p:sp>
@@ -8503,6 +8620,7 @@
           <a:lstStyle/>
           <a:p>
             <a:pPr algn="ctr"/>
+            <a:endParaRPr/>
           </a:p>
         </p:txBody>
       </p:sp>
@@ -8548,6 +8666,7 @@
           <a:lstStyle/>
           <a:p>
             <a:pPr algn="ctr"/>
+            <a:endParaRPr/>
           </a:p>
         </p:txBody>
       </p:sp>
@@ -8707,6 +8826,7 @@
           <a:lstStyle/>
           <a:p>
             <a:pPr algn="ctr"/>
+            <a:endParaRPr/>
           </a:p>
         </p:txBody>
       </p:sp>
@@ -8752,6 +8872,7 @@
           <a:lstStyle/>
           <a:p>
             <a:pPr algn="ctr"/>
+            <a:endParaRPr/>
           </a:p>
         </p:txBody>
       </p:sp>
@@ -8797,6 +8918,7 @@
           <a:lstStyle/>
           <a:p>
             <a:pPr algn="ctr"/>
+            <a:endParaRPr/>
           </a:p>
         </p:txBody>
       </p:sp>
@@ -8961,6 +9083,7 @@
           <a:lstStyle/>
           <a:p>
             <a:pPr algn="ctr"/>
+            <a:endParaRPr/>
           </a:p>
         </p:txBody>
       </p:sp>
@@ -9006,6 +9129,7 @@
           <a:lstStyle/>
           <a:p>
             <a:pPr algn="ctr"/>
+            <a:endParaRPr/>
           </a:p>
         </p:txBody>
       </p:sp>
@@ -9066,7 +9190,7 @@
 </file>
 
 <file path=ppt/slides/slide17.xml><?xml version="1.0" encoding="utf-8"?>
-<p:sld xmlns:a="http://schemas.openxmlformats.org/drawingml/2006/main" xmlns:p="http://schemas.openxmlformats.org/presentationml/2006/main" xmlns:r="http://schemas.openxmlformats.org/officeDocument/2006/relationships">
+<p:sld xmlns:a="http://schemas.openxmlformats.org/drawingml/2006/main" xmlns:r="http://schemas.openxmlformats.org/officeDocument/2006/relationships" xmlns:p="http://schemas.openxmlformats.org/presentationml/2006/main">
   <p:cSld>
     <p:spTree>
       <p:nvGrpSpPr>
@@ -9074,7 +9198,14 @@
         <p:cNvGrpSpPr/>
         <p:nvPr/>
       </p:nvGrpSpPr>
-      <p:grpSpPr/>
+      <p:grpSpPr>
+        <a:xfrm>
+          <a:off x="0" y="0"/>
+          <a:ext cx="0" cy="0"/>
+          <a:chOff x="0" y="0"/>
+          <a:chExt cx="0" cy="0"/>
+        </a:xfrm>
+      </p:grpSpPr>
       <p:sp>
         <p:nvSpPr>
           <p:cNvPr id="2" name="Rectangle 1"/>
@@ -9115,6 +9246,7 @@
           <a:lstStyle/>
           <a:p>
             <a:pPr algn="ctr"/>
+            <a:endParaRPr/>
           </a:p>
         </p:txBody>
       </p:sp>
@@ -9158,6 +9290,7 @@
           <a:lstStyle/>
           <a:p>
             <a:pPr algn="ctr"/>
+            <a:endParaRPr/>
           </a:p>
         </p:txBody>
       </p:sp>
@@ -9203,6 +9336,7 @@
           <a:lstStyle/>
           <a:p>
             <a:pPr algn="ctr"/>
+            <a:endParaRPr/>
           </a:p>
         </p:txBody>
       </p:sp>
@@ -9318,6 +9452,7 @@
           <a:lstStyle/>
           <a:p>
             <a:pPr algn="ctr"/>
+            <a:endParaRPr/>
           </a:p>
         </p:txBody>
       </p:sp>
@@ -9363,6 +9498,7 @@
           <a:lstStyle/>
           <a:p>
             <a:pPr algn="ctr"/>
+            <a:endParaRPr/>
           </a:p>
         </p:txBody>
       </p:sp>
@@ -9506,6 +9642,7 @@
           <a:lstStyle/>
           <a:p>
             <a:pPr algn="ctr"/>
+            <a:endParaRPr/>
           </a:p>
         </p:txBody>
       </p:sp>
@@ -9551,6 +9688,7 @@
           <a:lstStyle/>
           <a:p>
             <a:pPr algn="ctr"/>
+            <a:endParaRPr/>
           </a:p>
         </p:txBody>
       </p:sp>
@@ -9596,6 +9734,7 @@
           <a:lstStyle/>
           <a:p>
             <a:pPr algn="ctr"/>
+            <a:endParaRPr/>
           </a:p>
         </p:txBody>
       </p:sp>
@@ -9760,6 +9899,7 @@
           <a:lstStyle/>
           <a:p>
             <a:pPr algn="ctr"/>
+            <a:endParaRPr/>
           </a:p>
         </p:txBody>
       </p:sp>
@@ -9805,6 +9945,7 @@
           <a:lstStyle/>
           <a:p>
             <a:pPr algn="ctr"/>
+            <a:endParaRPr/>
           </a:p>
         </p:txBody>
       </p:sp>
@@ -9865,7 +10006,7 @@
 </file>
 
 <file path=ppt/slides/slide18.xml><?xml version="1.0" encoding="utf-8"?>
-<p:sld xmlns:a="http://schemas.openxmlformats.org/drawingml/2006/main" xmlns:p="http://schemas.openxmlformats.org/presentationml/2006/main" xmlns:r="http://schemas.openxmlformats.org/officeDocument/2006/relationships">
+<p:sld xmlns:a="http://schemas.openxmlformats.org/drawingml/2006/main" xmlns:r="http://schemas.openxmlformats.org/officeDocument/2006/relationships" xmlns:p="http://schemas.openxmlformats.org/presentationml/2006/main">
   <p:cSld>
     <p:spTree>
       <p:nvGrpSpPr>
@@ -9873,7 +10014,14 @@
         <p:cNvGrpSpPr/>
         <p:nvPr/>
       </p:nvGrpSpPr>
-      <p:grpSpPr/>
+      <p:grpSpPr>
+        <a:xfrm>
+          <a:off x="0" y="0"/>
+          <a:ext cx="0" cy="0"/>
+          <a:chOff x="0" y="0"/>
+          <a:chExt cx="0" cy="0"/>
+        </a:xfrm>
+      </p:grpSpPr>
       <p:sp>
         <p:nvSpPr>
           <p:cNvPr id="2" name="Rectangle 1"/>
@@ -9914,6 +10062,7 @@
           <a:lstStyle/>
           <a:p>
             <a:pPr algn="ctr"/>
+            <a:endParaRPr/>
           </a:p>
         </p:txBody>
       </p:sp>
@@ -9957,6 +10106,7 @@
           <a:lstStyle/>
           <a:p>
             <a:pPr algn="ctr"/>
+            <a:endParaRPr/>
           </a:p>
         </p:txBody>
       </p:sp>
@@ -10002,6 +10152,7 @@
           <a:lstStyle/>
           <a:p>
             <a:pPr algn="ctr"/>
+            <a:endParaRPr/>
           </a:p>
         </p:txBody>
       </p:sp>
@@ -10117,6 +10268,7 @@
           <a:lstStyle/>
           <a:p>
             <a:pPr algn="ctr"/>
+            <a:endParaRPr/>
           </a:p>
         </p:txBody>
       </p:sp>
@@ -10162,6 +10314,7 @@
           <a:lstStyle/>
           <a:p>
             <a:pPr algn="ctr"/>
+            <a:endParaRPr/>
           </a:p>
         </p:txBody>
       </p:sp>
@@ -10321,6 +10474,7 @@
           <a:lstStyle/>
           <a:p>
             <a:pPr algn="ctr"/>
+            <a:endParaRPr/>
           </a:p>
         </p:txBody>
       </p:sp>
@@ -10366,6 +10520,7 @@
           <a:lstStyle/>
           <a:p>
             <a:pPr algn="ctr"/>
+            <a:endParaRPr/>
           </a:p>
         </p:txBody>
       </p:sp>
@@ -10411,6 +10566,7 @@
           <a:lstStyle/>
           <a:p>
             <a:pPr algn="ctr"/>
+            <a:endParaRPr/>
           </a:p>
         </p:txBody>
       </p:sp>
@@ -10571,6 +10727,7 @@
           <a:lstStyle/>
           <a:p>
             <a:pPr algn="ctr"/>
+            <a:endParaRPr/>
           </a:p>
         </p:txBody>
       </p:sp>
@@ -10616,6 +10773,7 @@
           <a:lstStyle/>
           <a:p>
             <a:pPr algn="ctr"/>
+            <a:endParaRPr/>
           </a:p>
         </p:txBody>
       </p:sp>
@@ -10676,7 +10834,7 @@
 </file>
 
 <file path=ppt/slides/slide19.xml><?xml version="1.0" encoding="utf-8"?>
-<p:sld xmlns:a="http://schemas.openxmlformats.org/drawingml/2006/main" xmlns:p="http://schemas.openxmlformats.org/presentationml/2006/main" xmlns:r="http://schemas.openxmlformats.org/officeDocument/2006/relationships">
+<p:sld xmlns:a="http://schemas.openxmlformats.org/drawingml/2006/main" xmlns:r="http://schemas.openxmlformats.org/officeDocument/2006/relationships" xmlns:p="http://schemas.openxmlformats.org/presentationml/2006/main">
   <p:cSld>
     <p:spTree>
       <p:nvGrpSpPr>
@@ -10684,7 +10842,14 @@
         <p:cNvGrpSpPr/>
         <p:nvPr/>
       </p:nvGrpSpPr>
-      <p:grpSpPr/>
+      <p:grpSpPr>
+        <a:xfrm>
+          <a:off x="0" y="0"/>
+          <a:ext cx="0" cy="0"/>
+          <a:chOff x="0" y="0"/>
+          <a:chExt cx="0" cy="0"/>
+        </a:xfrm>
+      </p:grpSpPr>
       <p:sp>
         <p:nvSpPr>
           <p:cNvPr id="2" name="Rectangle 1"/>
@@ -10725,6 +10890,7 @@
           <a:lstStyle/>
           <a:p>
             <a:pPr algn="ctr"/>
+            <a:endParaRPr/>
           </a:p>
         </p:txBody>
       </p:sp>
@@ -10768,6 +10934,7 @@
           <a:lstStyle/>
           <a:p>
             <a:pPr algn="ctr"/>
+            <a:endParaRPr/>
           </a:p>
         </p:txBody>
       </p:sp>
@@ -10813,6 +10980,7 @@
           <a:lstStyle/>
           <a:p>
             <a:pPr algn="ctr"/>
+            <a:endParaRPr/>
           </a:p>
         </p:txBody>
       </p:sp>
@@ -10928,6 +11096,7 @@
           <a:lstStyle/>
           <a:p>
             <a:pPr algn="ctr"/>
+            <a:endParaRPr/>
           </a:p>
         </p:txBody>
       </p:sp>
@@ -10973,6 +11142,7 @@
           <a:lstStyle/>
           <a:p>
             <a:pPr algn="ctr"/>
+            <a:endParaRPr/>
           </a:p>
         </p:txBody>
       </p:sp>
@@ -11018,6 +11188,7 @@
           <a:lstStyle/>
           <a:p>
             <a:pPr algn="ctr"/>
+            <a:endParaRPr/>
           </a:p>
         </p:txBody>
       </p:sp>
@@ -11277,6 +11448,7 @@
           <a:lstStyle/>
           <a:p>
             <a:pPr algn="ctr"/>
+            <a:endParaRPr/>
           </a:p>
         </p:txBody>
       </p:sp>
@@ -11322,6 +11494,7 @@
           <a:lstStyle/>
           <a:p>
             <a:pPr algn="ctr"/>
+            <a:endParaRPr/>
           </a:p>
         </p:txBody>
       </p:sp>
@@ -11382,7 +11555,7 @@
 </file>
 
 <file path=ppt/slides/slide2.xml><?xml version="1.0" encoding="utf-8"?>
-<p:sld xmlns:a="http://schemas.openxmlformats.org/drawingml/2006/main" xmlns:p="http://schemas.openxmlformats.org/presentationml/2006/main" xmlns:r="http://schemas.openxmlformats.org/officeDocument/2006/relationships">
+<p:sld xmlns:a="http://schemas.openxmlformats.org/drawingml/2006/main" xmlns:r="http://schemas.openxmlformats.org/officeDocument/2006/relationships" xmlns:p="http://schemas.openxmlformats.org/presentationml/2006/main">
   <p:cSld>
     <p:spTree>
       <p:nvGrpSpPr>
@@ -11390,7 +11563,14 @@
         <p:cNvGrpSpPr/>
         <p:nvPr/>
       </p:nvGrpSpPr>
-      <p:grpSpPr/>
+      <p:grpSpPr>
+        <a:xfrm>
+          <a:off x="0" y="0"/>
+          <a:ext cx="0" cy="0"/>
+          <a:chOff x="0" y="0"/>
+          <a:chExt cx="0" cy="0"/>
+        </a:xfrm>
+      </p:grpSpPr>
       <p:sp>
         <p:nvSpPr>
           <p:cNvPr id="2" name="Rectangle 1"/>
@@ -11431,6 +11611,7 @@
           <a:lstStyle/>
           <a:p>
             <a:pPr algn="ctr"/>
+            <a:endParaRPr/>
           </a:p>
         </p:txBody>
       </p:sp>
@@ -11474,6 +11655,7 @@
           <a:lstStyle/>
           <a:p>
             <a:pPr algn="ctr"/>
+            <a:endParaRPr/>
           </a:p>
         </p:txBody>
       </p:sp>
@@ -11519,6 +11701,7 @@
           <a:lstStyle/>
           <a:p>
             <a:pPr algn="ctr"/>
+            <a:endParaRPr/>
           </a:p>
         </p:txBody>
       </p:sp>
@@ -11634,6 +11817,7 @@
           <a:lstStyle/>
           <a:p>
             <a:pPr algn="ctr"/>
+            <a:endParaRPr/>
           </a:p>
         </p:txBody>
       </p:sp>
@@ -11679,6 +11863,7 @@
           <a:lstStyle/>
           <a:p>
             <a:pPr algn="ctr"/>
+            <a:endParaRPr/>
           </a:p>
         </p:txBody>
       </p:sp>
@@ -11838,6 +12023,7 @@
           <a:lstStyle/>
           <a:p>
             <a:pPr algn="ctr"/>
+            <a:endParaRPr/>
           </a:p>
         </p:txBody>
       </p:sp>
@@ -11883,6 +12069,7 @@
           <a:lstStyle/>
           <a:p>
             <a:pPr algn="ctr"/>
+            <a:endParaRPr/>
           </a:p>
         </p:txBody>
       </p:sp>
@@ -11928,6 +12115,7 @@
           <a:lstStyle/>
           <a:p>
             <a:pPr algn="ctr"/>
+            <a:endParaRPr/>
           </a:p>
         </p:txBody>
       </p:sp>
@@ -12082,6 +12270,7 @@
           <a:lstStyle/>
           <a:p>
             <a:pPr algn="ctr"/>
+            <a:endParaRPr/>
           </a:p>
         </p:txBody>
       </p:sp>
@@ -12127,6 +12316,7 @@
           <a:lstStyle/>
           <a:p>
             <a:pPr algn="ctr"/>
+            <a:endParaRPr/>
           </a:p>
         </p:txBody>
       </p:sp>
@@ -12187,7 +12377,7 @@
 </file>
 
 <file path=ppt/slides/slide3.xml><?xml version="1.0" encoding="utf-8"?>
-<p:sld xmlns:a="http://schemas.openxmlformats.org/drawingml/2006/main" xmlns:p="http://schemas.openxmlformats.org/presentationml/2006/main" xmlns:r="http://schemas.openxmlformats.org/officeDocument/2006/relationships">
+<p:sld xmlns:a="http://schemas.openxmlformats.org/drawingml/2006/main" xmlns:r="http://schemas.openxmlformats.org/officeDocument/2006/relationships" xmlns:p="http://schemas.openxmlformats.org/presentationml/2006/main">
   <p:cSld>
     <p:spTree>
       <p:nvGrpSpPr>
@@ -12195,7 +12385,14 @@
         <p:cNvGrpSpPr/>
         <p:nvPr/>
       </p:nvGrpSpPr>
-      <p:grpSpPr/>
+      <p:grpSpPr>
+        <a:xfrm>
+          <a:off x="0" y="0"/>
+          <a:ext cx="0" cy="0"/>
+          <a:chOff x="0" y="0"/>
+          <a:chExt cx="0" cy="0"/>
+        </a:xfrm>
+      </p:grpSpPr>
       <p:sp>
         <p:nvSpPr>
           <p:cNvPr id="2" name="Rectangle 1"/>
@@ -12236,6 +12433,7 @@
           <a:lstStyle/>
           <a:p>
             <a:pPr algn="ctr"/>
+            <a:endParaRPr/>
           </a:p>
         </p:txBody>
       </p:sp>
@@ -12279,6 +12477,7 @@
           <a:lstStyle/>
           <a:p>
             <a:pPr algn="ctr"/>
+            <a:endParaRPr/>
           </a:p>
         </p:txBody>
       </p:sp>
@@ -12324,6 +12523,7 @@
           <a:lstStyle/>
           <a:p>
             <a:pPr algn="ctr"/>
+            <a:endParaRPr/>
           </a:p>
         </p:txBody>
       </p:sp>
@@ -12439,6 +12639,7 @@
           <a:lstStyle/>
           <a:p>
             <a:pPr algn="ctr"/>
+            <a:endParaRPr/>
           </a:p>
         </p:txBody>
       </p:sp>
@@ -12484,6 +12685,7 @@
           <a:lstStyle/>
           <a:p>
             <a:pPr algn="ctr"/>
+            <a:endParaRPr/>
           </a:p>
         </p:txBody>
       </p:sp>
@@ -12643,6 +12845,7 @@
           <a:lstStyle/>
           <a:p>
             <a:pPr algn="ctr"/>
+            <a:endParaRPr/>
           </a:p>
         </p:txBody>
       </p:sp>
@@ -12688,6 +12891,7 @@
           <a:lstStyle/>
           <a:p>
             <a:pPr algn="ctr"/>
+            <a:endParaRPr/>
           </a:p>
         </p:txBody>
       </p:sp>
@@ -12733,6 +12937,7 @@
           <a:lstStyle/>
           <a:p>
             <a:pPr algn="ctr"/>
+            <a:endParaRPr/>
           </a:p>
         </p:txBody>
       </p:sp>
@@ -12909,6 +13114,7 @@
           <a:lstStyle/>
           <a:p>
             <a:pPr algn="ctr"/>
+            <a:endParaRPr/>
           </a:p>
         </p:txBody>
       </p:sp>
@@ -12954,6 +13160,7 @@
           <a:lstStyle/>
           <a:p>
             <a:pPr algn="ctr"/>
+            <a:endParaRPr/>
           </a:p>
         </p:txBody>
       </p:sp>
@@ -13014,7 +13221,7 @@
 </file>
 
 <file path=ppt/slides/slide4.xml><?xml version="1.0" encoding="utf-8"?>
-<p:sld xmlns:a="http://schemas.openxmlformats.org/drawingml/2006/main" xmlns:p="http://schemas.openxmlformats.org/presentationml/2006/main" xmlns:r="http://schemas.openxmlformats.org/officeDocument/2006/relationships">
+<p:sld xmlns:a="http://schemas.openxmlformats.org/drawingml/2006/main" xmlns:r="http://schemas.openxmlformats.org/officeDocument/2006/relationships" xmlns:p="http://schemas.openxmlformats.org/presentationml/2006/main">
   <p:cSld>
     <p:spTree>
       <p:nvGrpSpPr>
@@ -13022,7 +13229,14 @@
         <p:cNvGrpSpPr/>
         <p:nvPr/>
       </p:nvGrpSpPr>
-      <p:grpSpPr/>
+      <p:grpSpPr>
+        <a:xfrm>
+          <a:off x="0" y="0"/>
+          <a:ext cx="0" cy="0"/>
+          <a:chOff x="0" y="0"/>
+          <a:chExt cx="0" cy="0"/>
+        </a:xfrm>
+      </p:grpSpPr>
       <p:sp>
         <p:nvSpPr>
           <p:cNvPr id="2" name="Rectangle 1"/>
@@ -13063,6 +13277,7 @@
           <a:lstStyle/>
           <a:p>
             <a:pPr algn="ctr"/>
+            <a:endParaRPr/>
           </a:p>
         </p:txBody>
       </p:sp>
@@ -13106,6 +13321,7 @@
           <a:lstStyle/>
           <a:p>
             <a:pPr algn="ctr"/>
+            <a:endParaRPr/>
           </a:p>
         </p:txBody>
       </p:sp>
@@ -13151,6 +13367,7 @@
           <a:lstStyle/>
           <a:p>
             <a:pPr algn="ctr"/>
+            <a:endParaRPr/>
           </a:p>
         </p:txBody>
       </p:sp>
@@ -13266,6 +13483,7 @@
           <a:lstStyle/>
           <a:p>
             <a:pPr algn="ctr"/>
+            <a:endParaRPr/>
           </a:p>
         </p:txBody>
       </p:sp>
@@ -13311,6 +13529,7 @@
           <a:lstStyle/>
           <a:p>
             <a:pPr algn="ctr"/>
+            <a:endParaRPr/>
           </a:p>
         </p:txBody>
       </p:sp>
@@ -13470,6 +13689,7 @@
           <a:lstStyle/>
           <a:p>
             <a:pPr algn="ctr"/>
+            <a:endParaRPr/>
           </a:p>
         </p:txBody>
       </p:sp>
@@ -13515,6 +13735,7 @@
           <a:lstStyle/>
           <a:p>
             <a:pPr algn="ctr"/>
+            <a:endParaRPr/>
           </a:p>
         </p:txBody>
       </p:sp>
@@ -13560,6 +13781,7 @@
           <a:lstStyle/>
           <a:p>
             <a:pPr algn="ctr"/>
+            <a:endParaRPr/>
           </a:p>
         </p:txBody>
       </p:sp>
@@ -13729,6 +13951,7 @@
           <a:lstStyle/>
           <a:p>
             <a:pPr algn="ctr"/>
+            <a:endParaRPr/>
           </a:p>
         </p:txBody>
       </p:sp>
@@ -13774,6 +13997,7 @@
           <a:lstStyle/>
           <a:p>
             <a:pPr algn="ctr"/>
+            <a:endParaRPr/>
           </a:p>
         </p:txBody>
       </p:sp>
@@ -13834,7 +14058,7 @@
 </file>
 
 <file path=ppt/slides/slide5.xml><?xml version="1.0" encoding="utf-8"?>
-<p:sld xmlns:a="http://schemas.openxmlformats.org/drawingml/2006/main" xmlns:p="http://schemas.openxmlformats.org/presentationml/2006/main" xmlns:r="http://schemas.openxmlformats.org/officeDocument/2006/relationships">
+<p:sld xmlns:a="http://schemas.openxmlformats.org/drawingml/2006/main" xmlns:r="http://schemas.openxmlformats.org/officeDocument/2006/relationships" xmlns:p="http://schemas.openxmlformats.org/presentationml/2006/main">
   <p:cSld>
     <p:spTree>
       <p:nvGrpSpPr>
@@ -13842,7 +14066,14 @@
         <p:cNvGrpSpPr/>
         <p:nvPr/>
       </p:nvGrpSpPr>
-      <p:grpSpPr/>
+      <p:grpSpPr>
+        <a:xfrm>
+          <a:off x="0" y="0"/>
+          <a:ext cx="0" cy="0"/>
+          <a:chOff x="0" y="0"/>
+          <a:chExt cx="0" cy="0"/>
+        </a:xfrm>
+      </p:grpSpPr>
       <p:sp>
         <p:nvSpPr>
           <p:cNvPr id="2" name="Rectangle 1"/>
@@ -13883,6 +14114,7 @@
           <a:lstStyle/>
           <a:p>
             <a:pPr algn="ctr"/>
+            <a:endParaRPr/>
           </a:p>
         </p:txBody>
       </p:sp>
@@ -13926,6 +14158,7 @@
           <a:lstStyle/>
           <a:p>
             <a:pPr algn="ctr"/>
+            <a:endParaRPr/>
           </a:p>
         </p:txBody>
       </p:sp>
@@ -13971,6 +14204,7 @@
           <a:lstStyle/>
           <a:p>
             <a:pPr algn="ctr"/>
+            <a:endParaRPr/>
           </a:p>
         </p:txBody>
       </p:sp>
@@ -14086,6 +14320,7 @@
           <a:lstStyle/>
           <a:p>
             <a:pPr algn="ctr"/>
+            <a:endParaRPr/>
           </a:p>
         </p:txBody>
       </p:sp>
@@ -14131,6 +14366,7 @@
           <a:lstStyle/>
           <a:p>
             <a:pPr algn="ctr"/>
+            <a:endParaRPr/>
           </a:p>
         </p:txBody>
       </p:sp>
@@ -14306,6 +14542,7 @@
           <a:lstStyle/>
           <a:p>
             <a:pPr algn="ctr"/>
+            <a:endParaRPr/>
           </a:p>
         </p:txBody>
       </p:sp>
@@ -14351,6 +14588,7 @@
           <a:lstStyle/>
           <a:p>
             <a:pPr algn="ctr"/>
+            <a:endParaRPr/>
           </a:p>
         </p:txBody>
       </p:sp>
@@ -14396,6 +14634,7 @@
           <a:lstStyle/>
           <a:p>
             <a:pPr algn="ctr"/>
+            <a:endParaRPr/>
           </a:p>
         </p:txBody>
       </p:sp>
@@ -14547,6 +14786,7 @@
           <a:lstStyle/>
           <a:p>
             <a:pPr algn="ctr"/>
+            <a:endParaRPr/>
           </a:p>
         </p:txBody>
       </p:sp>
@@ -14592,6 +14832,7 @@
           <a:lstStyle/>
           <a:p>
             <a:pPr algn="ctr"/>
+            <a:endParaRPr/>
           </a:p>
         </p:txBody>
       </p:sp>
@@ -14652,7 +14893,7 @@
 </file>
 
 <file path=ppt/slides/slide6.xml><?xml version="1.0" encoding="utf-8"?>
-<p:sld xmlns:a="http://schemas.openxmlformats.org/drawingml/2006/main" xmlns:p="http://schemas.openxmlformats.org/presentationml/2006/main" xmlns:r="http://schemas.openxmlformats.org/officeDocument/2006/relationships">
+<p:sld xmlns:a="http://schemas.openxmlformats.org/drawingml/2006/main" xmlns:r="http://schemas.openxmlformats.org/officeDocument/2006/relationships" xmlns:p="http://schemas.openxmlformats.org/presentationml/2006/main">
   <p:cSld>
     <p:spTree>
       <p:nvGrpSpPr>
@@ -14660,7 +14901,14 @@
         <p:cNvGrpSpPr/>
         <p:nvPr/>
       </p:nvGrpSpPr>
-      <p:grpSpPr/>
+      <p:grpSpPr>
+        <a:xfrm>
+          <a:off x="0" y="0"/>
+          <a:ext cx="0" cy="0"/>
+          <a:chOff x="0" y="0"/>
+          <a:chExt cx="0" cy="0"/>
+        </a:xfrm>
+      </p:grpSpPr>
       <p:sp>
         <p:nvSpPr>
           <p:cNvPr id="2" name="Rectangle 1"/>
@@ -14701,6 +14949,7 @@
           <a:lstStyle/>
           <a:p>
             <a:pPr algn="ctr"/>
+            <a:endParaRPr/>
           </a:p>
         </p:txBody>
       </p:sp>
@@ -14744,6 +14993,7 @@
           <a:lstStyle/>
           <a:p>
             <a:pPr algn="ctr"/>
+            <a:endParaRPr/>
           </a:p>
         </p:txBody>
       </p:sp>
@@ -14789,6 +15039,7 @@
           <a:lstStyle/>
           <a:p>
             <a:pPr algn="ctr"/>
+            <a:endParaRPr/>
           </a:p>
         </p:txBody>
       </p:sp>
@@ -14904,6 +15155,7 @@
           <a:lstStyle/>
           <a:p>
             <a:pPr algn="ctr"/>
+            <a:endParaRPr/>
           </a:p>
         </p:txBody>
       </p:sp>
@@ -14949,6 +15201,7 @@
           <a:lstStyle/>
           <a:p>
             <a:pPr algn="ctr"/>
+            <a:endParaRPr/>
           </a:p>
         </p:txBody>
       </p:sp>
@@ -15108,6 +15361,7 @@
           <a:lstStyle/>
           <a:p>
             <a:pPr algn="ctr"/>
+            <a:endParaRPr/>
           </a:p>
         </p:txBody>
       </p:sp>
@@ -15153,6 +15407,7 @@
           <a:lstStyle/>
           <a:p>
             <a:pPr algn="ctr"/>
+            <a:endParaRPr/>
           </a:p>
         </p:txBody>
       </p:sp>
@@ -15198,6 +15453,7 @@
           <a:lstStyle/>
           <a:p>
             <a:pPr algn="ctr"/>
+            <a:endParaRPr/>
           </a:p>
         </p:txBody>
       </p:sp>
@@ -15386,6 +15642,7 @@
           <a:lstStyle/>
           <a:p>
             <a:pPr algn="ctr"/>
+            <a:endParaRPr/>
           </a:p>
         </p:txBody>
       </p:sp>
@@ -15431,6 +15688,7 @@
           <a:lstStyle/>
           <a:p>
             <a:pPr algn="ctr"/>
+            <a:endParaRPr/>
           </a:p>
         </p:txBody>
       </p:sp>
@@ -15491,7 +15749,7 @@
 </file>
 
 <file path=ppt/slides/slide7.xml><?xml version="1.0" encoding="utf-8"?>
-<p:sld xmlns:a="http://schemas.openxmlformats.org/drawingml/2006/main" xmlns:p="http://schemas.openxmlformats.org/presentationml/2006/main" xmlns:r="http://schemas.openxmlformats.org/officeDocument/2006/relationships">
+<p:sld xmlns:a="http://schemas.openxmlformats.org/drawingml/2006/main" xmlns:r="http://schemas.openxmlformats.org/officeDocument/2006/relationships" xmlns:p="http://schemas.openxmlformats.org/presentationml/2006/main">
   <p:cSld>
     <p:spTree>
       <p:nvGrpSpPr>
@@ -15499,7 +15757,14 @@
         <p:cNvGrpSpPr/>
         <p:nvPr/>
       </p:nvGrpSpPr>
-      <p:grpSpPr/>
+      <p:grpSpPr>
+        <a:xfrm>
+          <a:off x="0" y="0"/>
+          <a:ext cx="0" cy="0"/>
+          <a:chOff x="0" y="0"/>
+          <a:chExt cx="0" cy="0"/>
+        </a:xfrm>
+      </p:grpSpPr>
       <p:sp>
         <p:nvSpPr>
           <p:cNvPr id="2" name="Rectangle 1"/>
@@ -15540,6 +15805,7 @@
           <a:lstStyle/>
           <a:p>
             <a:pPr algn="ctr"/>
+            <a:endParaRPr/>
           </a:p>
         </p:txBody>
       </p:sp>
@@ -15583,6 +15849,7 @@
           <a:lstStyle/>
           <a:p>
             <a:pPr algn="ctr"/>
+            <a:endParaRPr/>
           </a:p>
         </p:txBody>
       </p:sp>
@@ -15628,6 +15895,7 @@
           <a:lstStyle/>
           <a:p>
             <a:pPr algn="ctr"/>
+            <a:endParaRPr/>
           </a:p>
         </p:txBody>
       </p:sp>
@@ -15743,6 +16011,7 @@
           <a:lstStyle/>
           <a:p>
             <a:pPr algn="ctr"/>
+            <a:endParaRPr/>
           </a:p>
         </p:txBody>
       </p:sp>
@@ -15788,6 +16057,7 @@
           <a:lstStyle/>
           <a:p>
             <a:pPr algn="ctr"/>
+            <a:endParaRPr/>
           </a:p>
         </p:txBody>
       </p:sp>
@@ -15947,6 +16217,7 @@
           <a:lstStyle/>
           <a:p>
             <a:pPr algn="ctr"/>
+            <a:endParaRPr/>
           </a:p>
         </p:txBody>
       </p:sp>
@@ -15992,6 +16263,7 @@
           <a:lstStyle/>
           <a:p>
             <a:pPr algn="ctr"/>
+            <a:endParaRPr/>
           </a:p>
         </p:txBody>
       </p:sp>
@@ -16037,6 +16309,7 @@
           <a:lstStyle/>
           <a:p>
             <a:pPr algn="ctr"/>
+            <a:endParaRPr/>
           </a:p>
         </p:txBody>
       </p:sp>
@@ -16202,6 +16475,7 @@
           <a:lstStyle/>
           <a:p>
             <a:pPr algn="ctr"/>
+            <a:endParaRPr/>
           </a:p>
         </p:txBody>
       </p:sp>
@@ -16247,6 +16521,7 @@
           <a:lstStyle/>
           <a:p>
             <a:pPr algn="ctr"/>
+            <a:endParaRPr/>
           </a:p>
         </p:txBody>
       </p:sp>
@@ -16307,7 +16582,7 @@
 </file>
 
 <file path=ppt/slides/slide8.xml><?xml version="1.0" encoding="utf-8"?>
-<p:sld xmlns:a="http://schemas.openxmlformats.org/drawingml/2006/main" xmlns:p="http://schemas.openxmlformats.org/presentationml/2006/main" xmlns:r="http://schemas.openxmlformats.org/officeDocument/2006/relationships">
+<p:sld xmlns:a="http://schemas.openxmlformats.org/drawingml/2006/main" xmlns:r="http://schemas.openxmlformats.org/officeDocument/2006/relationships" xmlns:p="http://schemas.openxmlformats.org/presentationml/2006/main">
   <p:cSld>
     <p:spTree>
       <p:nvGrpSpPr>
@@ -16315,7 +16590,14 @@
         <p:cNvGrpSpPr/>
         <p:nvPr/>
       </p:nvGrpSpPr>
-      <p:grpSpPr/>
+      <p:grpSpPr>
+        <a:xfrm>
+          <a:off x="0" y="0"/>
+          <a:ext cx="0" cy="0"/>
+          <a:chOff x="0" y="0"/>
+          <a:chExt cx="0" cy="0"/>
+        </a:xfrm>
+      </p:grpSpPr>
       <p:sp>
         <p:nvSpPr>
           <p:cNvPr id="2" name="Rectangle 1"/>
@@ -16356,6 +16638,7 @@
           <a:lstStyle/>
           <a:p>
             <a:pPr algn="ctr"/>
+            <a:endParaRPr/>
           </a:p>
         </p:txBody>
       </p:sp>
@@ -16399,6 +16682,7 @@
           <a:lstStyle/>
           <a:p>
             <a:pPr algn="ctr"/>
+            <a:endParaRPr/>
           </a:p>
         </p:txBody>
       </p:sp>
@@ -16444,6 +16728,7 @@
           <a:lstStyle/>
           <a:p>
             <a:pPr algn="ctr"/>
+            <a:endParaRPr/>
           </a:p>
         </p:txBody>
       </p:sp>
@@ -16559,6 +16844,7 @@
           <a:lstStyle/>
           <a:p>
             <a:pPr algn="ctr"/>
+            <a:endParaRPr/>
           </a:p>
         </p:txBody>
       </p:sp>
@@ -16604,6 +16890,7 @@
           <a:lstStyle/>
           <a:p>
             <a:pPr algn="ctr"/>
+            <a:endParaRPr/>
           </a:p>
         </p:txBody>
       </p:sp>
@@ -16763,6 +17050,7 @@
           <a:lstStyle/>
           <a:p>
             <a:pPr algn="ctr"/>
+            <a:endParaRPr/>
           </a:p>
         </p:txBody>
       </p:sp>
@@ -16808,6 +17096,7 @@
           <a:lstStyle/>
           <a:p>
             <a:pPr algn="ctr"/>
+            <a:endParaRPr/>
           </a:p>
         </p:txBody>
       </p:sp>
@@ -16853,6 +17142,7 @@
           <a:lstStyle/>
           <a:p>
             <a:pPr algn="ctr"/>
+            <a:endParaRPr/>
           </a:p>
         </p:txBody>
       </p:sp>
@@ -17013,6 +17303,7 @@
           <a:lstStyle/>
           <a:p>
             <a:pPr algn="ctr"/>
+            <a:endParaRPr/>
           </a:p>
         </p:txBody>
       </p:sp>
@@ -17058,6 +17349,7 @@
           <a:lstStyle/>
           <a:p>
             <a:pPr algn="ctr"/>
+            <a:endParaRPr/>
           </a:p>
         </p:txBody>
       </p:sp>
@@ -17118,7 +17410,7 @@
 </file>
 
 <file path=ppt/slides/slide9.xml><?xml version="1.0" encoding="utf-8"?>
-<p:sld xmlns:a="http://schemas.openxmlformats.org/drawingml/2006/main" xmlns:p="http://schemas.openxmlformats.org/presentationml/2006/main" xmlns:r="http://schemas.openxmlformats.org/officeDocument/2006/relationships">
+<p:sld xmlns:a="http://schemas.openxmlformats.org/drawingml/2006/main" xmlns:r="http://schemas.openxmlformats.org/officeDocument/2006/relationships" xmlns:p="http://schemas.openxmlformats.org/presentationml/2006/main">
   <p:cSld>
     <p:spTree>
       <p:nvGrpSpPr>
@@ -17126,7 +17418,14 @@
         <p:cNvGrpSpPr/>
         <p:nvPr/>
       </p:nvGrpSpPr>
-      <p:grpSpPr/>
+      <p:grpSpPr>
+        <a:xfrm>
+          <a:off x="0" y="0"/>
+          <a:ext cx="0" cy="0"/>
+          <a:chOff x="0" y="0"/>
+          <a:chExt cx="0" cy="0"/>
+        </a:xfrm>
+      </p:grpSpPr>
       <p:sp>
         <p:nvSpPr>
           <p:cNvPr id="2" name="Rectangle 1"/>
@@ -17167,6 +17466,7 @@
           <a:lstStyle/>
           <a:p>
             <a:pPr algn="ctr"/>
+            <a:endParaRPr/>
           </a:p>
         </p:txBody>
       </p:sp>
@@ -17210,6 +17510,7 @@
           <a:lstStyle/>
           <a:p>
             <a:pPr algn="ctr"/>
+            <a:endParaRPr/>
           </a:p>
         </p:txBody>
       </p:sp>
@@ -17255,6 +17556,7 @@
           <a:lstStyle/>
           <a:p>
             <a:pPr algn="ctr"/>
+            <a:endParaRPr/>
           </a:p>
         </p:txBody>
       </p:sp>
@@ -17370,6 +17672,7 @@
           <a:lstStyle/>
           <a:p>
             <a:pPr algn="ctr"/>
+            <a:endParaRPr/>
           </a:p>
         </p:txBody>
       </p:sp>
@@ -17415,6 +17718,7 @@
           <a:lstStyle/>
           <a:p>
             <a:pPr algn="ctr"/>
+            <a:endParaRPr/>
           </a:p>
         </p:txBody>
       </p:sp>
@@ -17574,6 +17878,7 @@
           <a:lstStyle/>
           <a:p>
             <a:pPr algn="ctr"/>
+            <a:endParaRPr/>
           </a:p>
         </p:txBody>
       </p:sp>
@@ -17619,6 +17924,7 @@
           <a:lstStyle/>
           <a:p>
             <a:pPr algn="ctr"/>
+            <a:endParaRPr/>
           </a:p>
         </p:txBody>
       </p:sp>
@@ -17664,6 +17970,7 @@
           <a:lstStyle/>
           <a:p>
             <a:pPr algn="ctr"/>
+            <a:endParaRPr/>
           </a:p>
         </p:txBody>
       </p:sp>
@@ -17849,6 +18156,7 @@
           <a:lstStyle/>
           <a:p>
             <a:pPr algn="ctr"/>
+            <a:endParaRPr/>
           </a:p>
         </p:txBody>
       </p:sp>
@@ -17894,6 +18202,7 @@
           <a:lstStyle/>
           <a:p>
             <a:pPr algn="ctr"/>
+            <a:endParaRPr/>
           </a:p>
         </p:txBody>
       </p:sp>

</xml_diff>